<commit_message>
Optimize PPTX structure with premium card layouts, columns, and grid styling
</commit_message>
<xml_diff>
--- a/AI_Recruiter_Presentation.pptx
+++ b/AI_Recruiter_Presentation.pptx
@@ -3093,7 +3093,7 @@
     <p:bg>
       <p:bgPr>
         <a:solidFill>
-          <a:srgbClr val="0F0F1B"/>
+          <a:srgbClr val="0C0C14"/>
         </a:solidFill>
         <a:effectLst/>
       </p:bgPr>
@@ -3107,14 +3107,102 @@
       <p:grpSpPr/>
       <p:sp>
         <p:nvSpPr>
-          <p:cNvPr id="2" name="TextBox 1"/>
+          <p:cNvPr id="2" name="Rectangle 1"/>
+          <p:cNvSpPr/>
+          <p:nvPr/>
+        </p:nvSpPr>
+        <p:spPr>
+          <a:xfrm>
+            <a:off x="0" y="0"/>
+            <a:ext cx="365760" cy="6858000"/>
+          </a:xfrm>
+          <a:prstGeom prst="rect">
+            <a:avLst/>
+          </a:prstGeom>
+          <a:solidFill>
+            <a:srgbClr val="7928CA"/>
+          </a:solidFill>
+          <a:ln>
+            <a:noFill/>
+          </a:ln>
+        </p:spPr>
+        <p:style>
+          <a:lnRef idx="1">
+            <a:schemeClr val="accent1"/>
+          </a:lnRef>
+          <a:fillRef idx="3">
+            <a:schemeClr val="accent1"/>
+          </a:fillRef>
+          <a:effectRef idx="2">
+            <a:schemeClr val="accent1"/>
+          </a:effectRef>
+          <a:fontRef idx="minor">
+            <a:schemeClr val="lt1"/>
+          </a:fontRef>
+        </p:style>
+        <p:txBody>
+          <a:bodyPr rtlCol="0" anchor="ctr"/>
+          <a:lstStyle/>
+          <a:p>
+            <a:pPr algn="ctr"/>
+          </a:p>
+        </p:txBody>
+      </p:sp>
+      <p:sp>
+        <p:nvSpPr>
+          <p:cNvPr id="3" name="Rectangle 2"/>
+          <p:cNvSpPr/>
+          <p:nvPr/>
+        </p:nvSpPr>
+        <p:spPr>
+          <a:xfrm>
+            <a:off x="1097280" y="1097280"/>
+            <a:ext cx="9966960" cy="4663440"/>
+          </a:xfrm>
+          <a:prstGeom prst="rect">
+            <a:avLst/>
+          </a:prstGeom>
+          <a:solidFill>
+            <a:srgbClr val="161626"/>
+          </a:solidFill>
+          <a:ln w="19050">
+            <a:solidFill>
+              <a:srgbClr val="23233C"/>
+            </a:solidFill>
+          </a:ln>
+        </p:spPr>
+        <p:style>
+          <a:lnRef idx="1">
+            <a:schemeClr val="accent1"/>
+          </a:lnRef>
+          <a:fillRef idx="3">
+            <a:schemeClr val="accent1"/>
+          </a:fillRef>
+          <a:effectRef idx="2">
+            <a:schemeClr val="accent1"/>
+          </a:effectRef>
+          <a:fontRef idx="minor">
+            <a:schemeClr val="lt1"/>
+          </a:fontRef>
+        </p:style>
+        <p:txBody>
+          <a:bodyPr rtlCol="0" anchor="ctr"/>
+          <a:lstStyle/>
+          <a:p>
+            <a:pPr algn="ctr"/>
+          </a:p>
+        </p:txBody>
+      </p:sp>
+      <p:sp>
+        <p:nvSpPr>
+          <p:cNvPr id="4" name="TextBox 3"/>
           <p:cNvSpPr txBox="1"/>
           <p:nvPr/>
         </p:nvSpPr>
         <p:spPr>
           <a:xfrm>
-            <a:off x="914400" y="1371600"/>
-            <a:ext cx="10332720" cy="1371600"/>
+            <a:off x="1463040" y="1463040"/>
+            <a:ext cx="9235440" cy="3931920"/>
           </a:xfrm>
           <a:prstGeom prst="rect">
             <a:avLst/>
@@ -3136,35 +3224,15 @@
               </a:defRPr>
             </a:pPr>
             <a:r>
-              <a:t>AI Recruiter</a:t>
-            </a:r>
-          </a:p>
-        </p:txBody>
-      </p:sp>
-      <p:sp>
-        <p:nvSpPr>
-          <p:cNvPr id="3" name="TextBox 2"/>
-          <p:cNvSpPr txBox="1"/>
-          <p:nvPr/>
-        </p:nvSpPr>
-        <p:spPr>
-          <a:xfrm>
-            <a:off x="914400" y="2743200"/>
-            <a:ext cx="10332720" cy="1828800"/>
-          </a:xfrm>
-          <a:prstGeom prst="rect">
-            <a:avLst/>
-          </a:prstGeom>
-          <a:noFill/>
-        </p:spPr>
-        <p:txBody>
-          <a:bodyPr wrap="square">
-            <a:spAutoFit/>
-          </a:bodyPr>
-          <a:lstStyle/>
+              <a:t>AI RECRUITER</a:t>
+            </a:r>
+          </a:p>
           <a:p>
             <a:pPr>
-              <a:defRPr sz="2200">
+              <a:spcBef>
+                <a:spcPts val="1600"/>
+              </a:spcBef>
+              <a:defRPr sz="2000">
                 <a:solidFill>
                   <a:srgbClr val="FFFFFF"/>
                 </a:solidFill>
@@ -3180,32 +3248,12 @@
               <a:t>Automated Resume Ingestion, Semantic Matching, and Proctor-Secure AI Interviews</a:t>
             </a:r>
           </a:p>
-        </p:txBody>
-      </p:sp>
-      <p:sp>
-        <p:nvSpPr>
-          <p:cNvPr id="4" name="TextBox 3"/>
-          <p:cNvSpPr txBox="1"/>
-          <p:nvPr/>
-        </p:nvSpPr>
-        <p:spPr>
-          <a:xfrm>
-            <a:off x="914400" y="4754880"/>
-            <a:ext cx="10332720" cy="1371600"/>
-          </a:xfrm>
-          <a:prstGeom prst="rect">
-            <a:avLst/>
-          </a:prstGeom>
-          <a:noFill/>
-        </p:spPr>
-        <p:txBody>
-          <a:bodyPr wrap="square">
-            <a:spAutoFit/>
-          </a:bodyPr>
-          <a:lstStyle/>
           <a:p>
             <a:pPr>
-              <a:defRPr sz="1400">
+              <a:spcBef>
+                <a:spcPts val="3600"/>
+              </a:spcBef>
+              <a:defRPr sz="1350">
                 <a:solidFill>
                   <a:srgbClr val="A0A0B0"/>
                 </a:solidFill>
@@ -3240,7 +3288,7 @@
     <p:bg>
       <p:bgPr>
         <a:solidFill>
-          <a:srgbClr val="0F0F1B"/>
+          <a:srgbClr val="0C0C14"/>
         </a:solidFill>
         <a:effectLst/>
       </p:bgPr>
@@ -3260,8 +3308,8 @@
         </p:nvSpPr>
         <p:spPr>
           <a:xfrm>
-            <a:off x="731520" y="457200"/>
-            <a:ext cx="10698480" cy="914400"/>
+            <a:off x="731520" y="365760"/>
+            <a:ext cx="10698480" cy="731520"/>
           </a:xfrm>
           <a:prstGeom prst="rect">
             <a:avLst/>
@@ -3275,7 +3323,7 @@
           <a:lstStyle/>
           <a:p>
             <a:pPr>
-              <a:defRPr sz="3600" b="1">
+              <a:defRPr sz="3200" b="1">
                 <a:solidFill>
                   <a:srgbClr val="00DFD8"/>
                 </a:solidFill>
@@ -3290,14 +3338,145 @@
       </p:sp>
       <p:sp>
         <p:nvSpPr>
-          <p:cNvPr id="3" name="TextBox 2"/>
+          <p:cNvPr id="3" name="Rectangle 2"/>
+          <p:cNvSpPr/>
+          <p:nvPr/>
+        </p:nvSpPr>
+        <p:spPr>
+          <a:xfrm>
+            <a:off x="731520" y="1097280"/>
+            <a:ext cx="10728655" cy="19050"/>
+          </a:xfrm>
+          <a:prstGeom prst="rect">
+            <a:avLst/>
+          </a:prstGeom>
+          <a:solidFill>
+            <a:srgbClr val="23233C"/>
+          </a:solidFill>
+          <a:ln>
+            <a:noFill/>
+          </a:ln>
+        </p:spPr>
+        <p:style>
+          <a:lnRef idx="1">
+            <a:schemeClr val="accent1"/>
+          </a:lnRef>
+          <a:fillRef idx="3">
+            <a:schemeClr val="accent1"/>
+          </a:fillRef>
+          <a:effectRef idx="2">
+            <a:schemeClr val="accent1"/>
+          </a:effectRef>
+          <a:fontRef idx="minor">
+            <a:schemeClr val="lt1"/>
+          </a:fontRef>
+        </p:style>
+        <p:txBody>
+          <a:bodyPr rtlCol="0" anchor="ctr"/>
+          <a:lstStyle/>
+          <a:p>
+            <a:pPr algn="ctr"/>
+          </a:p>
+        </p:txBody>
+      </p:sp>
+      <p:sp>
+        <p:nvSpPr>
+          <p:cNvPr id="4" name="Rectangle 3"/>
+          <p:cNvSpPr/>
+          <p:nvPr/>
+        </p:nvSpPr>
+        <p:spPr>
+          <a:xfrm>
+            <a:off x="731520" y="1645920"/>
+            <a:ext cx="5120640" cy="4389120"/>
+          </a:xfrm>
+          <a:prstGeom prst="rect">
+            <a:avLst/>
+          </a:prstGeom>
+          <a:solidFill>
+            <a:srgbClr val="161626"/>
+          </a:solidFill>
+          <a:ln w="12700">
+            <a:solidFill>
+              <a:srgbClr val="23233C"/>
+            </a:solidFill>
+          </a:ln>
+        </p:spPr>
+        <p:style>
+          <a:lnRef idx="1">
+            <a:schemeClr val="accent1"/>
+          </a:lnRef>
+          <a:fillRef idx="3">
+            <a:schemeClr val="accent1"/>
+          </a:fillRef>
+          <a:effectRef idx="2">
+            <a:schemeClr val="accent1"/>
+          </a:effectRef>
+          <a:fontRef idx="minor">
+            <a:schemeClr val="lt1"/>
+          </a:fontRef>
+        </p:style>
+        <p:txBody>
+          <a:bodyPr rtlCol="0" anchor="ctr"/>
+          <a:lstStyle/>
+          <a:p>
+            <a:pPr algn="ctr"/>
+          </a:p>
+        </p:txBody>
+      </p:sp>
+      <p:sp>
+        <p:nvSpPr>
+          <p:cNvPr id="5" name="Rectangle 4"/>
+          <p:cNvSpPr/>
+          <p:nvPr/>
+        </p:nvSpPr>
+        <p:spPr>
+          <a:xfrm>
+            <a:off x="731520" y="1645920"/>
+            <a:ext cx="5120640" cy="50800"/>
+          </a:xfrm>
+          <a:prstGeom prst="rect">
+            <a:avLst/>
+          </a:prstGeom>
+          <a:solidFill>
+            <a:srgbClr val="7928CA"/>
+          </a:solidFill>
+          <a:ln>
+            <a:noFill/>
+          </a:ln>
+        </p:spPr>
+        <p:style>
+          <a:lnRef idx="1">
+            <a:schemeClr val="accent1"/>
+          </a:lnRef>
+          <a:fillRef idx="3">
+            <a:schemeClr val="accent1"/>
+          </a:fillRef>
+          <a:effectRef idx="2">
+            <a:schemeClr val="accent1"/>
+          </a:effectRef>
+          <a:fontRef idx="minor">
+            <a:schemeClr val="lt1"/>
+          </a:fontRef>
+        </p:style>
+        <p:txBody>
+          <a:bodyPr rtlCol="0" anchor="ctr"/>
+          <a:lstStyle/>
+          <a:p>
+            <a:pPr algn="ctr"/>
+          </a:p>
+        </p:txBody>
+      </p:sp>
+      <p:sp>
+        <p:nvSpPr>
+          <p:cNvPr id="6" name="TextBox 5"/>
           <p:cNvSpPr txBox="1"/>
           <p:nvPr/>
         </p:nvSpPr>
         <p:spPr>
           <a:xfrm>
-            <a:off x="731520" y="1645920"/>
-            <a:ext cx="10698480" cy="4572000"/>
+            <a:off x="1005840" y="1920240"/>
+            <a:ext cx="4572000" cy="3840480"/>
           </a:xfrm>
           <a:prstGeom prst="rect">
             <a:avLst/>
@@ -3311,9 +3490,9 @@
           <a:lstStyle/>
           <a:p>
             <a:pPr>
-              <a:spcBef>
+              <a:spcAft>
                 <a:spcPts val="1400"/>
-              </a:spcBef>
+              </a:spcAft>
               <a:defRPr sz="2000" b="1">
                 <a:solidFill>
                   <a:srgbClr val="00DFD8"/>
@@ -3328,9 +3507,9 @@
           <a:p>
             <a:pPr>
               <a:spcBef>
-                <a:spcPts val="400"/>
+                <a:spcPts val="600"/>
               </a:spcBef>
-              <a:defRPr sz="1500">
+              <a:defRPr sz="1450">
                 <a:solidFill>
                   <a:srgbClr val="FFFFFF"/>
                 </a:solidFill>
@@ -3339,30 +3518,157 @@
             </a:pPr>
             <a:r>
               <a:t>Delivered a complete, working, multi-role recruitment workflow featuring semantic vector search, LLM analysis, and anti-cheating screening.</a:t>
+            </a:r>
+          </a:p>
+        </p:txBody>
+      </p:sp>
+      <p:sp>
+        <p:nvSpPr>
+          <p:cNvPr id="7" name="Rectangle 6"/>
+          <p:cNvSpPr/>
+          <p:nvPr/>
+        </p:nvSpPr>
+        <p:spPr>
+          <a:xfrm>
+            <a:off x="6339535" y="1645920"/>
+            <a:ext cx="5120640" cy="4389120"/>
+          </a:xfrm>
+          <a:prstGeom prst="rect">
+            <a:avLst/>
+          </a:prstGeom>
+          <a:solidFill>
+            <a:srgbClr val="161626"/>
+          </a:solidFill>
+          <a:ln w="12700">
+            <a:solidFill>
+              <a:srgbClr val="23233C"/>
+            </a:solidFill>
+          </a:ln>
+        </p:spPr>
+        <p:style>
+          <a:lnRef idx="1">
+            <a:schemeClr val="accent1"/>
+          </a:lnRef>
+          <a:fillRef idx="3">
+            <a:schemeClr val="accent1"/>
+          </a:fillRef>
+          <a:effectRef idx="2">
+            <a:schemeClr val="accent1"/>
+          </a:effectRef>
+          <a:fontRef idx="minor">
+            <a:schemeClr val="lt1"/>
+          </a:fontRef>
+        </p:style>
+        <p:txBody>
+          <a:bodyPr rtlCol="0" anchor="ctr"/>
+          <a:lstStyle/>
+          <a:p>
+            <a:pPr algn="ctr"/>
+          </a:p>
+        </p:txBody>
+      </p:sp>
+      <p:sp>
+        <p:nvSpPr>
+          <p:cNvPr id="8" name="Rectangle 7"/>
+          <p:cNvSpPr/>
+          <p:nvPr/>
+        </p:nvSpPr>
+        <p:spPr>
+          <a:xfrm>
+            <a:off x="6339535" y="1645920"/>
+            <a:ext cx="5120640" cy="50800"/>
+          </a:xfrm>
+          <a:prstGeom prst="rect">
+            <a:avLst/>
+          </a:prstGeom>
+          <a:solidFill>
+            <a:srgbClr val="7928CA"/>
+          </a:solidFill>
+          <a:ln>
+            <a:noFill/>
+          </a:ln>
+        </p:spPr>
+        <p:style>
+          <a:lnRef idx="1">
+            <a:schemeClr val="accent1"/>
+          </a:lnRef>
+          <a:fillRef idx="3">
+            <a:schemeClr val="accent1"/>
+          </a:fillRef>
+          <a:effectRef idx="2">
+            <a:schemeClr val="accent1"/>
+          </a:effectRef>
+          <a:fontRef idx="minor">
+            <a:schemeClr val="lt1"/>
+          </a:fontRef>
+        </p:style>
+        <p:txBody>
+          <a:bodyPr rtlCol="0" anchor="ctr"/>
+          <a:lstStyle/>
+          <a:p>
+            <a:pPr algn="ctr"/>
+          </a:p>
+        </p:txBody>
+      </p:sp>
+      <p:sp>
+        <p:nvSpPr>
+          <p:cNvPr id="9" name="TextBox 8"/>
+          <p:cNvSpPr txBox="1"/>
+          <p:nvPr/>
+        </p:nvSpPr>
+        <p:spPr>
+          <a:xfrm>
+            <a:off x="6613855" y="1920240"/>
+            <a:ext cx="4572000" cy="3840480"/>
+          </a:xfrm>
+          <a:prstGeom prst="rect">
+            <a:avLst/>
+          </a:prstGeom>
+          <a:noFill/>
+        </p:spPr>
+        <p:txBody>
+          <a:bodyPr wrap="square">
+            <a:spAutoFit/>
+          </a:bodyPr>
+          <a:lstStyle/>
+          <a:p>
+            <a:pPr>
+              <a:spcAft>
+                <a:spcPts val="1400"/>
+              </a:spcAft>
+              <a:defRPr sz="2000" b="1">
+                <a:solidFill>
+                  <a:srgbClr val="00DFD8"/>
+                </a:solidFill>
+                <a:latin typeface="Segoe UI"/>
+              </a:defRPr>
+            </a:pPr>
+            <a:r>
+              <a:t>Future Extensions</a:t>
             </a:r>
           </a:p>
           <a:p>
             <a:pPr>
               <a:spcBef>
-                <a:spcPts val="1400"/>
+                <a:spcPts val="800"/>
               </a:spcBef>
-              <a:defRPr sz="2000" b="1">
-                <a:solidFill>
-                  <a:srgbClr val="00DFD8"/>
+              <a:defRPr sz="1450">
+                <a:solidFill>
+                  <a:srgbClr val="FFFFFF"/>
                 </a:solidFill>
                 <a:latin typeface="Segoe UI"/>
               </a:defRPr>
             </a:pPr>
             <a:r>
-              <a:t>Future Extensions</a:t>
+              <a:t>• Integrate WhatsApp outreach for faster candidate response times.</a:t>
             </a:r>
           </a:p>
           <a:p>
             <a:pPr>
               <a:spcBef>
-                <a:spcPts val="400"/>
+                <a:spcPts val="800"/>
               </a:spcBef>
-              <a:defRPr sz="1500">
+              <a:defRPr sz="1450">
                 <a:solidFill>
                   <a:srgbClr val="FFFFFF"/>
                 </a:solidFill>
@@ -3370,31 +3676,15 @@
               </a:defRPr>
             </a:pPr>
             <a:r>
-              <a:t>• Integrate WhatsApp outreach for faster candidate response times.</a:t>
+              <a:t>• Add voice biometrics to verify candidate identity and prevent proxy test-taking.</a:t>
             </a:r>
           </a:p>
           <a:p>
             <a:pPr>
               <a:spcBef>
-                <a:spcPts val="400"/>
+                <a:spcPts val="800"/>
               </a:spcBef>
-              <a:defRPr sz="1500">
-                <a:solidFill>
-                  <a:srgbClr val="FFFFFF"/>
-                </a:solidFill>
-                <a:latin typeface="Segoe UI"/>
-              </a:defRPr>
-            </a:pPr>
-            <a:r>
-              <a:t>• Add voice biometrics to verify candidate identity and prevent proxy test-taking.</a:t>
-            </a:r>
-          </a:p>
-          <a:p>
-            <a:pPr>
-              <a:spcBef>
-                <a:spcPts val="400"/>
-              </a:spcBef>
-              <a:defRPr sz="1500">
+              <a:defRPr sz="1450">
                 <a:solidFill>
                   <a:srgbClr val="FFFFFF"/>
                 </a:solidFill>
@@ -3421,7 +3711,7 @@
     <p:bg>
       <p:bgPr>
         <a:solidFill>
-          <a:srgbClr val="0F0F1B"/>
+          <a:srgbClr val="0C0C14"/>
         </a:solidFill>
         <a:effectLst/>
       </p:bgPr>
@@ -3441,8 +3731,8 @@
         </p:nvSpPr>
         <p:spPr>
           <a:xfrm>
-            <a:off x="731520" y="457200"/>
-            <a:ext cx="10698480" cy="914400"/>
+            <a:off x="731520" y="365760"/>
+            <a:ext cx="10698480" cy="731520"/>
           </a:xfrm>
           <a:prstGeom prst="rect">
             <a:avLst/>
@@ -3456,7 +3746,7 @@
           <a:lstStyle/>
           <a:p>
             <a:pPr>
-              <a:defRPr sz="3600" b="1">
+              <a:defRPr sz="3200" b="1">
                 <a:solidFill>
                   <a:srgbClr val="00DFD8"/>
                 </a:solidFill>
@@ -3471,14 +3761,145 @@
       </p:sp>
       <p:sp>
         <p:nvSpPr>
-          <p:cNvPr id="3" name="TextBox 2"/>
+          <p:cNvPr id="3" name="Rectangle 2"/>
+          <p:cNvSpPr/>
+          <p:nvPr/>
+        </p:nvSpPr>
+        <p:spPr>
+          <a:xfrm>
+            <a:off x="731520" y="1097280"/>
+            <a:ext cx="10728655" cy="19050"/>
+          </a:xfrm>
+          <a:prstGeom prst="rect">
+            <a:avLst/>
+          </a:prstGeom>
+          <a:solidFill>
+            <a:srgbClr val="23233C"/>
+          </a:solidFill>
+          <a:ln>
+            <a:noFill/>
+          </a:ln>
+        </p:spPr>
+        <p:style>
+          <a:lnRef idx="1">
+            <a:schemeClr val="accent1"/>
+          </a:lnRef>
+          <a:fillRef idx="3">
+            <a:schemeClr val="accent1"/>
+          </a:fillRef>
+          <a:effectRef idx="2">
+            <a:schemeClr val="accent1"/>
+          </a:effectRef>
+          <a:fontRef idx="minor">
+            <a:schemeClr val="lt1"/>
+          </a:fontRef>
+        </p:style>
+        <p:txBody>
+          <a:bodyPr rtlCol="0" anchor="ctr"/>
+          <a:lstStyle/>
+          <a:p>
+            <a:pPr algn="ctr"/>
+          </a:p>
+        </p:txBody>
+      </p:sp>
+      <p:sp>
+        <p:nvSpPr>
+          <p:cNvPr id="4" name="Rectangle 3"/>
+          <p:cNvSpPr/>
+          <p:nvPr/>
+        </p:nvSpPr>
+        <p:spPr>
+          <a:xfrm>
+            <a:off x="731520" y="1645920"/>
+            <a:ext cx="3328416" cy="4389120"/>
+          </a:xfrm>
+          <a:prstGeom prst="rect">
+            <a:avLst/>
+          </a:prstGeom>
+          <a:solidFill>
+            <a:srgbClr val="161626"/>
+          </a:solidFill>
+          <a:ln w="12700">
+            <a:solidFill>
+              <a:srgbClr val="23233C"/>
+            </a:solidFill>
+          </a:ln>
+        </p:spPr>
+        <p:style>
+          <a:lnRef idx="1">
+            <a:schemeClr val="accent1"/>
+          </a:lnRef>
+          <a:fillRef idx="3">
+            <a:schemeClr val="accent1"/>
+          </a:fillRef>
+          <a:effectRef idx="2">
+            <a:schemeClr val="accent1"/>
+          </a:effectRef>
+          <a:fontRef idx="minor">
+            <a:schemeClr val="lt1"/>
+          </a:fontRef>
+        </p:style>
+        <p:txBody>
+          <a:bodyPr rtlCol="0" anchor="ctr"/>
+          <a:lstStyle/>
+          <a:p>
+            <a:pPr algn="ctr"/>
+          </a:p>
+        </p:txBody>
+      </p:sp>
+      <p:sp>
+        <p:nvSpPr>
+          <p:cNvPr id="5" name="Rectangle 4"/>
+          <p:cNvSpPr/>
+          <p:nvPr/>
+        </p:nvSpPr>
+        <p:spPr>
+          <a:xfrm>
+            <a:off x="731520" y="1645920"/>
+            <a:ext cx="3328416" cy="50800"/>
+          </a:xfrm>
+          <a:prstGeom prst="rect">
+            <a:avLst/>
+          </a:prstGeom>
+          <a:solidFill>
+            <a:srgbClr val="00DFD8"/>
+          </a:solidFill>
+          <a:ln>
+            <a:noFill/>
+          </a:ln>
+        </p:spPr>
+        <p:style>
+          <a:lnRef idx="1">
+            <a:schemeClr val="accent1"/>
+          </a:lnRef>
+          <a:fillRef idx="3">
+            <a:schemeClr val="accent1"/>
+          </a:fillRef>
+          <a:effectRef idx="2">
+            <a:schemeClr val="accent1"/>
+          </a:effectRef>
+          <a:fontRef idx="minor">
+            <a:schemeClr val="lt1"/>
+          </a:fontRef>
+        </p:style>
+        <p:txBody>
+          <a:bodyPr rtlCol="0" anchor="ctr"/>
+          <a:lstStyle/>
+          <a:p>
+            <a:pPr algn="ctr"/>
+          </a:p>
+        </p:txBody>
+      </p:sp>
+      <p:sp>
+        <p:nvSpPr>
+          <p:cNvPr id="6" name="TextBox 5"/>
           <p:cNvSpPr txBox="1"/>
           <p:nvPr/>
         </p:nvSpPr>
         <p:spPr>
           <a:xfrm>
-            <a:off x="731520" y="1645920"/>
-            <a:ext cx="10698480" cy="4572000"/>
+            <a:off x="914400" y="1920240"/>
+            <a:ext cx="2962656" cy="3931920"/>
           </a:xfrm>
           <a:prstGeom prst="rect">
             <a:avLst/>
@@ -3492,10 +3913,10 @@
           <a:lstStyle/>
           <a:p>
             <a:pPr>
-              <a:spcBef>
-                <a:spcPts val="1400"/>
-              </a:spcBef>
-              <a:defRPr sz="2000" b="1">
+              <a:spcAft>
+                <a:spcPts val="1200"/>
+              </a:spcAft>
+              <a:defRPr sz="1800" b="1">
                 <a:solidFill>
                   <a:srgbClr val="00DFD8"/>
                 </a:solidFill>
@@ -3511,7 +3932,7 @@
               <a:spcBef>
                 <a:spcPts val="400"/>
               </a:spcBef>
-              <a:defRPr sz="1500">
+              <a:defRPr sz="1350">
                 <a:solidFill>
                   <a:srgbClr val="FFFFFF"/>
                 </a:solidFill>
@@ -3522,12 +3943,123 @@
               <a:t>Traditional recruitment software filters profiles using literal keyword matches, missing highly qualified candidates who describe their skills differently.</a:t>
             </a:r>
           </a:p>
+        </p:txBody>
+      </p:sp>
+      <p:sp>
+        <p:nvSpPr>
+          <p:cNvPr id="7" name="Rectangle 6"/>
+          <p:cNvSpPr/>
+          <p:nvPr/>
+        </p:nvSpPr>
+        <p:spPr>
+          <a:xfrm>
+            <a:off x="4425696" y="1645920"/>
+            <a:ext cx="3328416" cy="4389120"/>
+          </a:xfrm>
+          <a:prstGeom prst="rect">
+            <a:avLst/>
+          </a:prstGeom>
+          <a:solidFill>
+            <a:srgbClr val="161626"/>
+          </a:solidFill>
+          <a:ln w="12700">
+            <a:solidFill>
+              <a:srgbClr val="23233C"/>
+            </a:solidFill>
+          </a:ln>
+        </p:spPr>
+        <p:style>
+          <a:lnRef idx="1">
+            <a:schemeClr val="accent1"/>
+          </a:lnRef>
+          <a:fillRef idx="3">
+            <a:schemeClr val="accent1"/>
+          </a:fillRef>
+          <a:effectRef idx="2">
+            <a:schemeClr val="accent1"/>
+          </a:effectRef>
+          <a:fontRef idx="minor">
+            <a:schemeClr val="lt1"/>
+          </a:fontRef>
+        </p:style>
+        <p:txBody>
+          <a:bodyPr rtlCol="0" anchor="ctr"/>
+          <a:lstStyle/>
+          <a:p>
+            <a:pPr algn="ctr"/>
+          </a:p>
+        </p:txBody>
+      </p:sp>
+      <p:sp>
+        <p:nvSpPr>
+          <p:cNvPr id="8" name="Rectangle 7"/>
+          <p:cNvSpPr/>
+          <p:nvPr/>
+        </p:nvSpPr>
+        <p:spPr>
+          <a:xfrm>
+            <a:off x="4425696" y="1645920"/>
+            <a:ext cx="3328416" cy="50800"/>
+          </a:xfrm>
+          <a:prstGeom prst="rect">
+            <a:avLst/>
+          </a:prstGeom>
+          <a:solidFill>
+            <a:srgbClr val="00DFD8"/>
+          </a:solidFill>
+          <a:ln>
+            <a:noFill/>
+          </a:ln>
+        </p:spPr>
+        <p:style>
+          <a:lnRef idx="1">
+            <a:schemeClr val="accent1"/>
+          </a:lnRef>
+          <a:fillRef idx="3">
+            <a:schemeClr val="accent1"/>
+          </a:fillRef>
+          <a:effectRef idx="2">
+            <a:schemeClr val="accent1"/>
+          </a:effectRef>
+          <a:fontRef idx="minor">
+            <a:schemeClr val="lt1"/>
+          </a:fontRef>
+        </p:style>
+        <p:txBody>
+          <a:bodyPr rtlCol="0" anchor="ctr"/>
+          <a:lstStyle/>
+          <a:p>
+            <a:pPr algn="ctr"/>
+          </a:p>
+        </p:txBody>
+      </p:sp>
+      <p:sp>
+        <p:nvSpPr>
+          <p:cNvPr id="9" name="TextBox 8"/>
+          <p:cNvSpPr txBox="1"/>
+          <p:nvPr/>
+        </p:nvSpPr>
+        <p:spPr>
+          <a:xfrm>
+            <a:off x="4608576" y="1920240"/>
+            <a:ext cx="2962656" cy="3931920"/>
+          </a:xfrm>
+          <a:prstGeom prst="rect">
+            <a:avLst/>
+          </a:prstGeom>
+          <a:noFill/>
+        </p:spPr>
+        <p:txBody>
+          <a:bodyPr wrap="square">
+            <a:spAutoFit/>
+          </a:bodyPr>
+          <a:lstStyle/>
           <a:p>
             <a:pPr>
-              <a:spcBef>
-                <a:spcPts val="1400"/>
-              </a:spcBef>
-              <a:defRPr sz="2000" b="1">
+              <a:spcAft>
+                <a:spcPts val="1200"/>
+              </a:spcAft>
+              <a:defRPr sz="1800" b="1">
                 <a:solidFill>
                   <a:srgbClr val="00DFD8"/>
                 </a:solidFill>
@@ -3543,7 +4075,7 @@
               <a:spcBef>
                 <a:spcPts val="400"/>
               </a:spcBef>
-              <a:defRPr sz="1500">
+              <a:defRPr sz="1350">
                 <a:solidFill>
                   <a:srgbClr val="FFFFFF"/>
                 </a:solidFill>
@@ -3554,12 +4086,123 @@
               <a:t>Manual resume reviews are slow and subject to recruiter bias, leading to inconsistent evaluations and missed matches.</a:t>
             </a:r>
           </a:p>
+        </p:txBody>
+      </p:sp>
+      <p:sp>
+        <p:nvSpPr>
+          <p:cNvPr id="10" name="Rectangle 9"/>
+          <p:cNvSpPr/>
+          <p:nvPr/>
+        </p:nvSpPr>
+        <p:spPr>
+          <a:xfrm>
+            <a:off x="8119872" y="1645920"/>
+            <a:ext cx="3328416" cy="4389120"/>
+          </a:xfrm>
+          <a:prstGeom prst="rect">
+            <a:avLst/>
+          </a:prstGeom>
+          <a:solidFill>
+            <a:srgbClr val="161626"/>
+          </a:solidFill>
+          <a:ln w="12700">
+            <a:solidFill>
+              <a:srgbClr val="23233C"/>
+            </a:solidFill>
+          </a:ln>
+        </p:spPr>
+        <p:style>
+          <a:lnRef idx="1">
+            <a:schemeClr val="accent1"/>
+          </a:lnRef>
+          <a:fillRef idx="3">
+            <a:schemeClr val="accent1"/>
+          </a:fillRef>
+          <a:effectRef idx="2">
+            <a:schemeClr val="accent1"/>
+          </a:effectRef>
+          <a:fontRef idx="minor">
+            <a:schemeClr val="lt1"/>
+          </a:fontRef>
+        </p:style>
+        <p:txBody>
+          <a:bodyPr rtlCol="0" anchor="ctr"/>
+          <a:lstStyle/>
+          <a:p>
+            <a:pPr algn="ctr"/>
+          </a:p>
+        </p:txBody>
+      </p:sp>
+      <p:sp>
+        <p:nvSpPr>
+          <p:cNvPr id="11" name="Rectangle 10"/>
+          <p:cNvSpPr/>
+          <p:nvPr/>
+        </p:nvSpPr>
+        <p:spPr>
+          <a:xfrm>
+            <a:off x="8119872" y="1645920"/>
+            <a:ext cx="3328416" cy="50800"/>
+          </a:xfrm>
+          <a:prstGeom prst="rect">
+            <a:avLst/>
+          </a:prstGeom>
+          <a:solidFill>
+            <a:srgbClr val="00DFD8"/>
+          </a:solidFill>
+          <a:ln>
+            <a:noFill/>
+          </a:ln>
+        </p:spPr>
+        <p:style>
+          <a:lnRef idx="1">
+            <a:schemeClr val="accent1"/>
+          </a:lnRef>
+          <a:fillRef idx="3">
+            <a:schemeClr val="accent1"/>
+          </a:fillRef>
+          <a:effectRef idx="2">
+            <a:schemeClr val="accent1"/>
+          </a:effectRef>
+          <a:fontRef idx="minor">
+            <a:schemeClr val="lt1"/>
+          </a:fontRef>
+        </p:style>
+        <p:txBody>
+          <a:bodyPr rtlCol="0" anchor="ctr"/>
+          <a:lstStyle/>
+          <a:p>
+            <a:pPr algn="ctr"/>
+          </a:p>
+        </p:txBody>
+      </p:sp>
+      <p:sp>
+        <p:nvSpPr>
+          <p:cNvPr id="12" name="TextBox 11"/>
+          <p:cNvSpPr txBox="1"/>
+          <p:nvPr/>
+        </p:nvSpPr>
+        <p:spPr>
+          <a:xfrm>
+            <a:off x="8302752" y="1920240"/>
+            <a:ext cx="2962656" cy="3931920"/>
+          </a:xfrm>
+          <a:prstGeom prst="rect">
+            <a:avLst/>
+          </a:prstGeom>
+          <a:noFill/>
+        </p:spPr>
+        <p:txBody>
+          <a:bodyPr wrap="square">
+            <a:spAutoFit/>
+          </a:bodyPr>
+          <a:lstStyle/>
           <a:p>
             <a:pPr>
-              <a:spcBef>
-                <a:spcPts val="1400"/>
-              </a:spcBef>
-              <a:defRPr sz="2000" b="1">
+              <a:spcAft>
+                <a:spcPts val="1200"/>
+              </a:spcAft>
+              <a:defRPr sz="1800" b="1">
                 <a:solidFill>
                   <a:srgbClr val="00DFD8"/>
                 </a:solidFill>
@@ -3575,7 +4218,7 @@
               <a:spcBef>
                 <a:spcPts val="400"/>
               </a:spcBef>
-              <a:defRPr sz="1500">
+              <a:defRPr sz="1350">
                 <a:solidFill>
                   <a:srgbClr val="FFFFFF"/>
                 </a:solidFill>
@@ -3602,7 +4245,7 @@
     <p:bg>
       <p:bgPr>
         <a:solidFill>
-          <a:srgbClr val="0F0F1B"/>
+          <a:srgbClr val="0C0C14"/>
         </a:solidFill>
         <a:effectLst/>
       </p:bgPr>
@@ -3622,8 +4265,8 @@
         </p:nvSpPr>
         <p:spPr>
           <a:xfrm>
-            <a:off x="731520" y="457200"/>
-            <a:ext cx="10698480" cy="914400"/>
+            <a:off x="731520" y="365760"/>
+            <a:ext cx="10698480" cy="731520"/>
           </a:xfrm>
           <a:prstGeom prst="rect">
             <a:avLst/>
@@ -3637,7 +4280,7 @@
           <a:lstStyle/>
           <a:p>
             <a:pPr>
-              <a:defRPr sz="3600" b="1">
+              <a:defRPr sz="3200" b="1">
                 <a:solidFill>
                   <a:srgbClr val="00DFD8"/>
                 </a:solidFill>
@@ -3652,14 +4295,145 @@
       </p:sp>
       <p:sp>
         <p:nvSpPr>
-          <p:cNvPr id="3" name="TextBox 2"/>
+          <p:cNvPr id="3" name="Rectangle 2"/>
+          <p:cNvSpPr/>
+          <p:nvPr/>
+        </p:nvSpPr>
+        <p:spPr>
+          <a:xfrm>
+            <a:off x="731520" y="1097280"/>
+            <a:ext cx="10728655" cy="19050"/>
+          </a:xfrm>
+          <a:prstGeom prst="rect">
+            <a:avLst/>
+          </a:prstGeom>
+          <a:solidFill>
+            <a:srgbClr val="23233C"/>
+          </a:solidFill>
+          <a:ln>
+            <a:noFill/>
+          </a:ln>
+        </p:spPr>
+        <p:style>
+          <a:lnRef idx="1">
+            <a:schemeClr val="accent1"/>
+          </a:lnRef>
+          <a:fillRef idx="3">
+            <a:schemeClr val="accent1"/>
+          </a:fillRef>
+          <a:effectRef idx="2">
+            <a:schemeClr val="accent1"/>
+          </a:effectRef>
+          <a:fontRef idx="minor">
+            <a:schemeClr val="lt1"/>
+          </a:fontRef>
+        </p:style>
+        <p:txBody>
+          <a:bodyPr rtlCol="0" anchor="ctr"/>
+          <a:lstStyle/>
+          <a:p>
+            <a:pPr algn="ctr"/>
+          </a:p>
+        </p:txBody>
+      </p:sp>
+      <p:sp>
+        <p:nvSpPr>
+          <p:cNvPr id="4" name="Rectangle 3"/>
+          <p:cNvSpPr/>
+          <p:nvPr/>
+        </p:nvSpPr>
+        <p:spPr>
+          <a:xfrm>
+            <a:off x="731520" y="1645920"/>
+            <a:ext cx="3328416" cy="4389120"/>
+          </a:xfrm>
+          <a:prstGeom prst="rect">
+            <a:avLst/>
+          </a:prstGeom>
+          <a:solidFill>
+            <a:srgbClr val="161626"/>
+          </a:solidFill>
+          <a:ln w="12700">
+            <a:solidFill>
+              <a:srgbClr val="23233C"/>
+            </a:solidFill>
+          </a:ln>
+        </p:spPr>
+        <p:style>
+          <a:lnRef idx="1">
+            <a:schemeClr val="accent1"/>
+          </a:lnRef>
+          <a:fillRef idx="3">
+            <a:schemeClr val="accent1"/>
+          </a:fillRef>
+          <a:effectRef idx="2">
+            <a:schemeClr val="accent1"/>
+          </a:effectRef>
+          <a:fontRef idx="minor">
+            <a:schemeClr val="lt1"/>
+          </a:fontRef>
+        </p:style>
+        <p:txBody>
+          <a:bodyPr rtlCol="0" anchor="ctr"/>
+          <a:lstStyle/>
+          <a:p>
+            <a:pPr algn="ctr"/>
+          </a:p>
+        </p:txBody>
+      </p:sp>
+      <p:sp>
+        <p:nvSpPr>
+          <p:cNvPr id="5" name="Rectangle 4"/>
+          <p:cNvSpPr/>
+          <p:nvPr/>
+        </p:nvSpPr>
+        <p:spPr>
+          <a:xfrm>
+            <a:off x="731520" y="1645920"/>
+            <a:ext cx="3328416" cy="50800"/>
+          </a:xfrm>
+          <a:prstGeom prst="rect">
+            <a:avLst/>
+          </a:prstGeom>
+          <a:solidFill>
+            <a:srgbClr val="00DFD8"/>
+          </a:solidFill>
+          <a:ln>
+            <a:noFill/>
+          </a:ln>
+        </p:spPr>
+        <p:style>
+          <a:lnRef idx="1">
+            <a:schemeClr val="accent1"/>
+          </a:lnRef>
+          <a:fillRef idx="3">
+            <a:schemeClr val="accent1"/>
+          </a:fillRef>
+          <a:effectRef idx="2">
+            <a:schemeClr val="accent1"/>
+          </a:effectRef>
+          <a:fontRef idx="minor">
+            <a:schemeClr val="lt1"/>
+          </a:fontRef>
+        </p:style>
+        <p:txBody>
+          <a:bodyPr rtlCol="0" anchor="ctr"/>
+          <a:lstStyle/>
+          <a:p>
+            <a:pPr algn="ctr"/>
+          </a:p>
+        </p:txBody>
+      </p:sp>
+      <p:sp>
+        <p:nvSpPr>
+          <p:cNvPr id="6" name="TextBox 5"/>
           <p:cNvSpPr txBox="1"/>
           <p:nvPr/>
         </p:nvSpPr>
         <p:spPr>
           <a:xfrm>
-            <a:off x="731520" y="1645920"/>
-            <a:ext cx="10698480" cy="4572000"/>
+            <a:off x="914400" y="1920240"/>
+            <a:ext cx="2962656" cy="3931920"/>
           </a:xfrm>
           <a:prstGeom prst="rect">
             <a:avLst/>
@@ -3673,10 +4447,10 @@
           <a:lstStyle/>
           <a:p>
             <a:pPr>
-              <a:spcBef>
-                <a:spcPts val="1400"/>
-              </a:spcBef>
-              <a:defRPr sz="2000" b="1">
+              <a:spcAft>
+                <a:spcPts val="1200"/>
+              </a:spcAft>
+              <a:defRPr sz="1800" b="1">
                 <a:solidFill>
                   <a:srgbClr val="00DFD8"/>
                 </a:solidFill>
@@ -3684,7 +4458,7 @@
               </a:defRPr>
             </a:pPr>
             <a:r>
-              <a:t>Double-Layer Candidate Screening</a:t>
+              <a:t>Double-Layer Screening</a:t>
             </a:r>
           </a:p>
           <a:p>
@@ -3692,7 +4466,7 @@
               <a:spcBef>
                 <a:spcPts val="400"/>
               </a:spcBef>
-              <a:defRPr sz="1500">
+              <a:defRPr sz="1350">
                 <a:solidFill>
                   <a:srgbClr val="FFFFFF"/>
                 </a:solidFill>
@@ -3700,19 +4474,139 @@
               </a:defRPr>
             </a:pPr>
             <a:r>
-              <a:t>• Layer 1 (Semantic Similarity): Filter matches instantly based on context and meaning, not just keywords.</a:t>
+              <a:t>• Layer 1 (Semantic Filtering):</a:t>
             </a:r>
             <a:br/>
             <a:r>
-              <a:t>• Layer 2 (Deep LLM Scoring): Uses Google Gemini 2.0 Flash to evaluate candidate fit, list pros/cons, and write feedback.</a:t>
-            </a:r>
-          </a:p>
+              <a:t>Matches candidates instantly based on context and meaning, not just keywords.</a:t>
+            </a:r>
+            <a:br/>
+            <a:br/>
+            <a:r>
+              <a:t>• Layer 2 (Deep LLM Scoring):</a:t>
+            </a:r>
+            <a:br/>
+            <a:r>
+              <a:t>Uses Gemini 2.0 Flash to evaluate fit, list pros/cons, and generate feedback.</a:t>
+            </a:r>
+          </a:p>
+        </p:txBody>
+      </p:sp>
+      <p:sp>
+        <p:nvSpPr>
+          <p:cNvPr id="7" name="Rectangle 6"/>
+          <p:cNvSpPr/>
+          <p:nvPr/>
+        </p:nvSpPr>
+        <p:spPr>
+          <a:xfrm>
+            <a:off x="4425696" y="1645920"/>
+            <a:ext cx="3328416" cy="4389120"/>
+          </a:xfrm>
+          <a:prstGeom prst="rect">
+            <a:avLst/>
+          </a:prstGeom>
+          <a:solidFill>
+            <a:srgbClr val="161626"/>
+          </a:solidFill>
+          <a:ln w="12700">
+            <a:solidFill>
+              <a:srgbClr val="23233C"/>
+            </a:solidFill>
+          </a:ln>
+        </p:spPr>
+        <p:style>
+          <a:lnRef idx="1">
+            <a:schemeClr val="accent1"/>
+          </a:lnRef>
+          <a:fillRef idx="3">
+            <a:schemeClr val="accent1"/>
+          </a:fillRef>
+          <a:effectRef idx="2">
+            <a:schemeClr val="accent1"/>
+          </a:effectRef>
+          <a:fontRef idx="minor">
+            <a:schemeClr val="lt1"/>
+          </a:fontRef>
+        </p:style>
+        <p:txBody>
+          <a:bodyPr rtlCol="0" anchor="ctr"/>
+          <a:lstStyle/>
+          <a:p>
+            <a:pPr algn="ctr"/>
+          </a:p>
+        </p:txBody>
+      </p:sp>
+      <p:sp>
+        <p:nvSpPr>
+          <p:cNvPr id="8" name="Rectangle 7"/>
+          <p:cNvSpPr/>
+          <p:nvPr/>
+        </p:nvSpPr>
+        <p:spPr>
+          <a:xfrm>
+            <a:off x="4425696" y="1645920"/>
+            <a:ext cx="3328416" cy="50800"/>
+          </a:xfrm>
+          <a:prstGeom prst="rect">
+            <a:avLst/>
+          </a:prstGeom>
+          <a:solidFill>
+            <a:srgbClr val="00DFD8"/>
+          </a:solidFill>
+          <a:ln>
+            <a:noFill/>
+          </a:ln>
+        </p:spPr>
+        <p:style>
+          <a:lnRef idx="1">
+            <a:schemeClr val="accent1"/>
+          </a:lnRef>
+          <a:fillRef idx="3">
+            <a:schemeClr val="accent1"/>
+          </a:fillRef>
+          <a:effectRef idx="2">
+            <a:schemeClr val="accent1"/>
+          </a:effectRef>
+          <a:fontRef idx="minor">
+            <a:schemeClr val="lt1"/>
+          </a:fontRef>
+        </p:style>
+        <p:txBody>
+          <a:bodyPr rtlCol="0" anchor="ctr"/>
+          <a:lstStyle/>
+          <a:p>
+            <a:pPr algn="ctr"/>
+          </a:p>
+        </p:txBody>
+      </p:sp>
+      <p:sp>
+        <p:nvSpPr>
+          <p:cNvPr id="9" name="TextBox 8"/>
+          <p:cNvSpPr txBox="1"/>
+          <p:nvPr/>
+        </p:nvSpPr>
+        <p:spPr>
+          <a:xfrm>
+            <a:off x="4608576" y="1920240"/>
+            <a:ext cx="2962656" cy="3931920"/>
+          </a:xfrm>
+          <a:prstGeom prst="rect">
+            <a:avLst/>
+          </a:prstGeom>
+          <a:noFill/>
+        </p:spPr>
+        <p:txBody>
+          <a:bodyPr wrap="square">
+            <a:spAutoFit/>
+          </a:bodyPr>
+          <a:lstStyle/>
           <a:p>
             <a:pPr>
-              <a:spcBef>
-                <a:spcPts val="1400"/>
-              </a:spcBef>
-              <a:defRPr sz="2000" b="1">
+              <a:spcAft>
+                <a:spcPts val="1200"/>
+              </a:spcAft>
+              <a:defRPr sz="1800" b="1">
                 <a:solidFill>
                   <a:srgbClr val="00DFD8"/>
                 </a:solidFill>
@@ -3720,7 +4614,7 @@
               </a:defRPr>
             </a:pPr>
             <a:r>
-              <a:t>Conversational AI Screening Hub</a:t>
+              <a:t>AI Screening Hub</a:t>
             </a:r>
           </a:p>
           <a:p>
@@ -3728,7 +4622,7 @@
               <a:spcBef>
                 <a:spcPts val="400"/>
               </a:spcBef>
-              <a:defRPr sz="1500">
+              <a:defRPr sz="1350">
                 <a:solidFill>
                   <a:srgbClr val="FFFFFF"/>
                 </a:solidFill>
@@ -3736,15 +4630,126 @@
               </a:defRPr>
             </a:pPr>
             <a:r>
-              <a:t>Interactive, voice-driven screening interview with built-in behavioral telemetry to flag cheating or tab-switching in real-time.</a:t>
-            </a:r>
-          </a:p>
+              <a:t>An interactive, voice-driven screening interview with built-in behavioral telemetry to flag focus-loss or tab-switching in real-time.</a:t>
+            </a:r>
+          </a:p>
+        </p:txBody>
+      </p:sp>
+      <p:sp>
+        <p:nvSpPr>
+          <p:cNvPr id="10" name="Rectangle 9"/>
+          <p:cNvSpPr/>
+          <p:nvPr/>
+        </p:nvSpPr>
+        <p:spPr>
+          <a:xfrm>
+            <a:off x="8119872" y="1645920"/>
+            <a:ext cx="3328416" cy="4389120"/>
+          </a:xfrm>
+          <a:prstGeom prst="rect">
+            <a:avLst/>
+          </a:prstGeom>
+          <a:solidFill>
+            <a:srgbClr val="161626"/>
+          </a:solidFill>
+          <a:ln w="12700">
+            <a:solidFill>
+              <a:srgbClr val="23233C"/>
+            </a:solidFill>
+          </a:ln>
+        </p:spPr>
+        <p:style>
+          <a:lnRef idx="1">
+            <a:schemeClr val="accent1"/>
+          </a:lnRef>
+          <a:fillRef idx="3">
+            <a:schemeClr val="accent1"/>
+          </a:fillRef>
+          <a:effectRef idx="2">
+            <a:schemeClr val="accent1"/>
+          </a:effectRef>
+          <a:fontRef idx="minor">
+            <a:schemeClr val="lt1"/>
+          </a:fontRef>
+        </p:style>
+        <p:txBody>
+          <a:bodyPr rtlCol="0" anchor="ctr"/>
+          <a:lstStyle/>
+          <a:p>
+            <a:pPr algn="ctr"/>
+          </a:p>
+        </p:txBody>
+      </p:sp>
+      <p:sp>
+        <p:nvSpPr>
+          <p:cNvPr id="11" name="Rectangle 10"/>
+          <p:cNvSpPr/>
+          <p:nvPr/>
+        </p:nvSpPr>
+        <p:spPr>
+          <a:xfrm>
+            <a:off x="8119872" y="1645920"/>
+            <a:ext cx="3328416" cy="50800"/>
+          </a:xfrm>
+          <a:prstGeom prst="rect">
+            <a:avLst/>
+          </a:prstGeom>
+          <a:solidFill>
+            <a:srgbClr val="00DFD8"/>
+          </a:solidFill>
+          <a:ln>
+            <a:noFill/>
+          </a:ln>
+        </p:spPr>
+        <p:style>
+          <a:lnRef idx="1">
+            <a:schemeClr val="accent1"/>
+          </a:lnRef>
+          <a:fillRef idx="3">
+            <a:schemeClr val="accent1"/>
+          </a:fillRef>
+          <a:effectRef idx="2">
+            <a:schemeClr val="accent1"/>
+          </a:effectRef>
+          <a:fontRef idx="minor">
+            <a:schemeClr val="lt1"/>
+          </a:fontRef>
+        </p:style>
+        <p:txBody>
+          <a:bodyPr rtlCol="0" anchor="ctr"/>
+          <a:lstStyle/>
+          <a:p>
+            <a:pPr algn="ctr"/>
+          </a:p>
+        </p:txBody>
+      </p:sp>
+      <p:sp>
+        <p:nvSpPr>
+          <p:cNvPr id="12" name="TextBox 11"/>
+          <p:cNvSpPr txBox="1"/>
+          <p:nvPr/>
+        </p:nvSpPr>
+        <p:spPr>
+          <a:xfrm>
+            <a:off x="8302752" y="1920240"/>
+            <a:ext cx="2962656" cy="3931920"/>
+          </a:xfrm>
+          <a:prstGeom prst="rect">
+            <a:avLst/>
+          </a:prstGeom>
+          <a:noFill/>
+        </p:spPr>
+        <p:txBody>
+          <a:bodyPr wrap="square">
+            <a:spAutoFit/>
+          </a:bodyPr>
+          <a:lstStyle/>
           <a:p>
             <a:pPr>
-              <a:spcBef>
-                <a:spcPts val="1400"/>
-              </a:spcBef>
-              <a:defRPr sz="2000" b="1">
+              <a:spcAft>
+                <a:spcPts val="1200"/>
+              </a:spcAft>
+              <a:defRPr sz="1800" b="1">
                 <a:solidFill>
                   <a:srgbClr val="00DFD8"/>
                 </a:solidFill>
@@ -3760,7 +4765,7 @@
               <a:spcBef>
                 <a:spcPts val="400"/>
               </a:spcBef>
-              <a:defRPr sz="1500">
+              <a:defRPr sz="1350">
                 <a:solidFill>
                   <a:srgbClr val="FFFFFF"/>
                 </a:solidFill>
@@ -3787,7 +4792,7 @@
     <p:bg>
       <p:bgPr>
         <a:solidFill>
-          <a:srgbClr val="0F0F1B"/>
+          <a:srgbClr val="0C0C14"/>
         </a:solidFill>
         <a:effectLst/>
       </p:bgPr>
@@ -3807,8 +4812,8 @@
         </p:nvSpPr>
         <p:spPr>
           <a:xfrm>
-            <a:off x="731520" y="457200"/>
-            <a:ext cx="10698480" cy="914400"/>
+            <a:off x="731520" y="365760"/>
+            <a:ext cx="10698480" cy="731520"/>
           </a:xfrm>
           <a:prstGeom prst="rect">
             <a:avLst/>
@@ -3822,7 +4827,7 @@
           <a:lstStyle/>
           <a:p>
             <a:pPr>
-              <a:defRPr sz="3600" b="1">
+              <a:defRPr sz="3200" b="1">
                 <a:solidFill>
                   <a:srgbClr val="00DFD8"/>
                 </a:solidFill>
@@ -3837,14 +4842,145 @@
       </p:sp>
       <p:sp>
         <p:nvSpPr>
-          <p:cNvPr id="3" name="TextBox 2"/>
+          <p:cNvPr id="3" name="Rectangle 2"/>
+          <p:cNvSpPr/>
+          <p:nvPr/>
+        </p:nvSpPr>
+        <p:spPr>
+          <a:xfrm>
+            <a:off x="731520" y="1097280"/>
+            <a:ext cx="10728655" cy="19050"/>
+          </a:xfrm>
+          <a:prstGeom prst="rect">
+            <a:avLst/>
+          </a:prstGeom>
+          <a:solidFill>
+            <a:srgbClr val="23233C"/>
+          </a:solidFill>
+          <a:ln>
+            <a:noFill/>
+          </a:ln>
+        </p:spPr>
+        <p:style>
+          <a:lnRef idx="1">
+            <a:schemeClr val="accent1"/>
+          </a:lnRef>
+          <a:fillRef idx="3">
+            <a:schemeClr val="accent1"/>
+          </a:fillRef>
+          <a:effectRef idx="2">
+            <a:schemeClr val="accent1"/>
+          </a:effectRef>
+          <a:fontRef idx="minor">
+            <a:schemeClr val="lt1"/>
+          </a:fontRef>
+        </p:style>
+        <p:txBody>
+          <a:bodyPr rtlCol="0" anchor="ctr"/>
+          <a:lstStyle/>
+          <a:p>
+            <a:pPr algn="ctr"/>
+          </a:p>
+        </p:txBody>
+      </p:sp>
+      <p:sp>
+        <p:nvSpPr>
+          <p:cNvPr id="4" name="Rectangle 3"/>
+          <p:cNvSpPr/>
+          <p:nvPr/>
+        </p:nvSpPr>
+        <p:spPr>
+          <a:xfrm>
+            <a:off x="731520" y="1645920"/>
+            <a:ext cx="5120640" cy="2011680"/>
+          </a:xfrm>
+          <a:prstGeom prst="rect">
+            <a:avLst/>
+          </a:prstGeom>
+          <a:solidFill>
+            <a:srgbClr val="161626"/>
+          </a:solidFill>
+          <a:ln w="12700">
+            <a:solidFill>
+              <a:srgbClr val="23233C"/>
+            </a:solidFill>
+          </a:ln>
+        </p:spPr>
+        <p:style>
+          <a:lnRef idx="1">
+            <a:schemeClr val="accent1"/>
+          </a:lnRef>
+          <a:fillRef idx="3">
+            <a:schemeClr val="accent1"/>
+          </a:fillRef>
+          <a:effectRef idx="2">
+            <a:schemeClr val="accent1"/>
+          </a:effectRef>
+          <a:fontRef idx="minor">
+            <a:schemeClr val="lt1"/>
+          </a:fontRef>
+        </p:style>
+        <p:txBody>
+          <a:bodyPr rtlCol="0" anchor="ctr"/>
+          <a:lstStyle/>
+          <a:p>
+            <a:pPr algn="ctr"/>
+          </a:p>
+        </p:txBody>
+      </p:sp>
+      <p:sp>
+        <p:nvSpPr>
+          <p:cNvPr id="5" name="Rectangle 4"/>
+          <p:cNvSpPr/>
+          <p:nvPr/>
+        </p:nvSpPr>
+        <p:spPr>
+          <a:xfrm>
+            <a:off x="731520" y="1645920"/>
+            <a:ext cx="50800" cy="2011680"/>
+          </a:xfrm>
+          <a:prstGeom prst="rect">
+            <a:avLst/>
+          </a:prstGeom>
+          <a:solidFill>
+            <a:srgbClr val="7928CA"/>
+          </a:solidFill>
+          <a:ln>
+            <a:noFill/>
+          </a:ln>
+        </p:spPr>
+        <p:style>
+          <a:lnRef idx="1">
+            <a:schemeClr val="accent1"/>
+          </a:lnRef>
+          <a:fillRef idx="3">
+            <a:schemeClr val="accent1"/>
+          </a:fillRef>
+          <a:effectRef idx="2">
+            <a:schemeClr val="accent1"/>
+          </a:effectRef>
+          <a:fontRef idx="minor">
+            <a:schemeClr val="lt1"/>
+          </a:fontRef>
+        </p:style>
+        <p:txBody>
+          <a:bodyPr rtlCol="0" anchor="ctr"/>
+          <a:lstStyle/>
+          <a:p>
+            <a:pPr algn="ctr"/>
+          </a:p>
+        </p:txBody>
+      </p:sp>
+      <p:sp>
+        <p:nvSpPr>
+          <p:cNvPr id="6" name="TextBox 5"/>
           <p:cNvSpPr txBox="1"/>
           <p:nvPr/>
         </p:nvSpPr>
         <p:spPr>
           <a:xfrm>
-            <a:off x="731520" y="1645920"/>
-            <a:ext cx="10698480" cy="4572000"/>
+            <a:off x="960120" y="1828800"/>
+            <a:ext cx="4754880" cy="1645920"/>
           </a:xfrm>
           <a:prstGeom prst="rect">
             <a:avLst/>
@@ -3858,10 +4994,10 @@
           <a:lstStyle/>
           <a:p>
             <a:pPr>
-              <a:spcBef>
-                <a:spcPts val="1400"/>
-              </a:spcBef>
-              <a:defRPr sz="2000" b="1">
+              <a:spcAft>
+                <a:spcPts val="600"/>
+              </a:spcAft>
+              <a:defRPr sz="1800" b="1">
                 <a:solidFill>
                   <a:srgbClr val="00DFD8"/>
                 </a:solidFill>
@@ -3877,7 +5013,7 @@
               <a:spcBef>
                 <a:spcPts val="400"/>
               </a:spcBef>
-              <a:defRPr sz="1500">
+              <a:defRPr sz="1350">
                 <a:solidFill>
                   <a:srgbClr val="FFFFFF"/>
                 </a:solidFill>
@@ -3888,12 +5024,123 @@
               <a:t>Recruiter creates a job description, which the Google Gemini LLM parses into structured Must-Have and Nice-to-Have skills, experience level, and role summary.</a:t>
             </a:r>
           </a:p>
+        </p:txBody>
+      </p:sp>
+      <p:sp>
+        <p:nvSpPr>
+          <p:cNvPr id="7" name="Rectangle 6"/>
+          <p:cNvSpPr/>
+          <p:nvPr/>
+        </p:nvSpPr>
+        <p:spPr>
+          <a:xfrm>
+            <a:off x="6339535" y="1645920"/>
+            <a:ext cx="5120640" cy="2011680"/>
+          </a:xfrm>
+          <a:prstGeom prst="rect">
+            <a:avLst/>
+          </a:prstGeom>
+          <a:solidFill>
+            <a:srgbClr val="161626"/>
+          </a:solidFill>
+          <a:ln w="12700">
+            <a:solidFill>
+              <a:srgbClr val="23233C"/>
+            </a:solidFill>
+          </a:ln>
+        </p:spPr>
+        <p:style>
+          <a:lnRef idx="1">
+            <a:schemeClr val="accent1"/>
+          </a:lnRef>
+          <a:fillRef idx="3">
+            <a:schemeClr val="accent1"/>
+          </a:fillRef>
+          <a:effectRef idx="2">
+            <a:schemeClr val="accent1"/>
+          </a:effectRef>
+          <a:fontRef idx="minor">
+            <a:schemeClr val="lt1"/>
+          </a:fontRef>
+        </p:style>
+        <p:txBody>
+          <a:bodyPr rtlCol="0" anchor="ctr"/>
+          <a:lstStyle/>
+          <a:p>
+            <a:pPr algn="ctr"/>
+          </a:p>
+        </p:txBody>
+      </p:sp>
+      <p:sp>
+        <p:nvSpPr>
+          <p:cNvPr id="8" name="Rectangle 7"/>
+          <p:cNvSpPr/>
+          <p:nvPr/>
+        </p:nvSpPr>
+        <p:spPr>
+          <a:xfrm>
+            <a:off x="6339535" y="1645920"/>
+            <a:ext cx="50800" cy="2011680"/>
+          </a:xfrm>
+          <a:prstGeom prst="rect">
+            <a:avLst/>
+          </a:prstGeom>
+          <a:solidFill>
+            <a:srgbClr val="7928CA"/>
+          </a:solidFill>
+          <a:ln>
+            <a:noFill/>
+          </a:ln>
+        </p:spPr>
+        <p:style>
+          <a:lnRef idx="1">
+            <a:schemeClr val="accent1"/>
+          </a:lnRef>
+          <a:fillRef idx="3">
+            <a:schemeClr val="accent1"/>
+          </a:fillRef>
+          <a:effectRef idx="2">
+            <a:schemeClr val="accent1"/>
+          </a:effectRef>
+          <a:fontRef idx="minor">
+            <a:schemeClr val="lt1"/>
+          </a:fontRef>
+        </p:style>
+        <p:txBody>
+          <a:bodyPr rtlCol="0" anchor="ctr"/>
+          <a:lstStyle/>
+          <a:p>
+            <a:pPr algn="ctr"/>
+          </a:p>
+        </p:txBody>
+      </p:sp>
+      <p:sp>
+        <p:nvSpPr>
+          <p:cNvPr id="9" name="TextBox 8"/>
+          <p:cNvSpPr txBox="1"/>
+          <p:nvPr/>
+        </p:nvSpPr>
+        <p:spPr>
+          <a:xfrm>
+            <a:off x="6568135" y="1828800"/>
+            <a:ext cx="4754880" cy="1645920"/>
+          </a:xfrm>
+          <a:prstGeom prst="rect">
+            <a:avLst/>
+          </a:prstGeom>
+          <a:noFill/>
+        </p:spPr>
+        <p:txBody>
+          <a:bodyPr wrap="square">
+            <a:spAutoFit/>
+          </a:bodyPr>
+          <a:lstStyle/>
           <a:p>
             <a:pPr>
-              <a:spcBef>
-                <a:spcPts val="1400"/>
-              </a:spcBef>
-              <a:defRPr sz="2000" b="1">
+              <a:spcAft>
+                <a:spcPts val="600"/>
+              </a:spcAft>
+              <a:defRPr sz="1800" b="1">
                 <a:solidFill>
                   <a:srgbClr val="00DFD8"/>
                 </a:solidFill>
@@ -3901,7 +5148,7 @@
               </a:defRPr>
             </a:pPr>
             <a:r>
-              <a:t>2. Resume Upload &amp; Processing</a:t>
+              <a:t>2. Ingestion &amp; Extraction</a:t>
             </a:r>
           </a:p>
           <a:p>
@@ -3909,7 +5156,7 @@
               <a:spcBef>
                 <a:spcPts val="400"/>
               </a:spcBef>
-              <a:defRPr sz="1500">
+              <a:defRPr sz="1350">
                 <a:solidFill>
                   <a:srgbClr val="FFFFFF"/>
                 </a:solidFill>
@@ -3920,12 +5167,123 @@
               <a:t>Ingests candidate profiles (via CSV/PDF). Cleans and extracts names, emails, phones, and parsed text automatically.</a:t>
             </a:r>
           </a:p>
+        </p:txBody>
+      </p:sp>
+      <p:sp>
+        <p:nvSpPr>
+          <p:cNvPr id="10" name="Rectangle 9"/>
+          <p:cNvSpPr/>
+          <p:nvPr/>
+        </p:nvSpPr>
+        <p:spPr>
+          <a:xfrm>
+            <a:off x="731520" y="4023360"/>
+            <a:ext cx="5120640" cy="2011680"/>
+          </a:xfrm>
+          <a:prstGeom prst="rect">
+            <a:avLst/>
+          </a:prstGeom>
+          <a:solidFill>
+            <a:srgbClr val="161626"/>
+          </a:solidFill>
+          <a:ln w="12700">
+            <a:solidFill>
+              <a:srgbClr val="23233C"/>
+            </a:solidFill>
+          </a:ln>
+        </p:spPr>
+        <p:style>
+          <a:lnRef idx="1">
+            <a:schemeClr val="accent1"/>
+          </a:lnRef>
+          <a:fillRef idx="3">
+            <a:schemeClr val="accent1"/>
+          </a:fillRef>
+          <a:effectRef idx="2">
+            <a:schemeClr val="accent1"/>
+          </a:effectRef>
+          <a:fontRef idx="minor">
+            <a:schemeClr val="lt1"/>
+          </a:fontRef>
+        </p:style>
+        <p:txBody>
+          <a:bodyPr rtlCol="0" anchor="ctr"/>
+          <a:lstStyle/>
+          <a:p>
+            <a:pPr algn="ctr"/>
+          </a:p>
+        </p:txBody>
+      </p:sp>
+      <p:sp>
+        <p:nvSpPr>
+          <p:cNvPr id="11" name="Rectangle 10"/>
+          <p:cNvSpPr/>
+          <p:nvPr/>
+        </p:nvSpPr>
+        <p:spPr>
+          <a:xfrm>
+            <a:off x="731520" y="4023360"/>
+            <a:ext cx="50800" cy="2011680"/>
+          </a:xfrm>
+          <a:prstGeom prst="rect">
+            <a:avLst/>
+          </a:prstGeom>
+          <a:solidFill>
+            <a:srgbClr val="7928CA"/>
+          </a:solidFill>
+          <a:ln>
+            <a:noFill/>
+          </a:ln>
+        </p:spPr>
+        <p:style>
+          <a:lnRef idx="1">
+            <a:schemeClr val="accent1"/>
+          </a:lnRef>
+          <a:fillRef idx="3">
+            <a:schemeClr val="accent1"/>
+          </a:fillRef>
+          <a:effectRef idx="2">
+            <a:schemeClr val="accent1"/>
+          </a:effectRef>
+          <a:fontRef idx="minor">
+            <a:schemeClr val="lt1"/>
+          </a:fontRef>
+        </p:style>
+        <p:txBody>
+          <a:bodyPr rtlCol="0" anchor="ctr"/>
+          <a:lstStyle/>
+          <a:p>
+            <a:pPr algn="ctr"/>
+          </a:p>
+        </p:txBody>
+      </p:sp>
+      <p:sp>
+        <p:nvSpPr>
+          <p:cNvPr id="12" name="TextBox 11"/>
+          <p:cNvSpPr txBox="1"/>
+          <p:nvPr/>
+        </p:nvSpPr>
+        <p:spPr>
+          <a:xfrm>
+            <a:off x="960120" y="4206240"/>
+            <a:ext cx="4754880" cy="1645920"/>
+          </a:xfrm>
+          <a:prstGeom prst="rect">
+            <a:avLst/>
+          </a:prstGeom>
+          <a:noFill/>
+        </p:spPr>
+        <p:txBody>
+          <a:bodyPr wrap="square">
+            <a:spAutoFit/>
+          </a:bodyPr>
+          <a:lstStyle/>
           <a:p>
             <a:pPr>
-              <a:spcBef>
-                <a:spcPts val="1400"/>
-              </a:spcBef>
-              <a:defRPr sz="2000" b="1">
+              <a:spcAft>
+                <a:spcPts val="600"/>
+              </a:spcAft>
+              <a:defRPr sz="1800" b="1">
                 <a:solidFill>
                   <a:srgbClr val="00DFD8"/>
                 </a:solidFill>
@@ -3933,7 +5291,7 @@
               </a:defRPr>
             </a:pPr>
             <a:r>
-              <a:t>3. Vector Similarity matching</a:t>
+              <a:t>3. Vector Matching</a:t>
             </a:r>
           </a:p>
           <a:p>
@@ -3941,7 +5299,7 @@
               <a:spcBef>
                 <a:spcPts val="400"/>
               </a:spcBef>
-              <a:defRPr sz="1500">
+              <a:defRPr sz="1350">
                 <a:solidFill>
                   <a:srgbClr val="FFFFFF"/>
                 </a:solidFill>
@@ -3952,12 +5310,123 @@
               <a:t>Calculates dense 384-dimensional semantic embeddings. Computes cosine similarity of candidate profiles against the job description requirements.</a:t>
             </a:r>
           </a:p>
+        </p:txBody>
+      </p:sp>
+      <p:sp>
+        <p:nvSpPr>
+          <p:cNvPr id="13" name="Rectangle 12"/>
+          <p:cNvSpPr/>
+          <p:nvPr/>
+        </p:nvSpPr>
+        <p:spPr>
+          <a:xfrm>
+            <a:off x="6339535" y="4023360"/>
+            <a:ext cx="5120640" cy="2011680"/>
+          </a:xfrm>
+          <a:prstGeom prst="rect">
+            <a:avLst/>
+          </a:prstGeom>
+          <a:solidFill>
+            <a:srgbClr val="161626"/>
+          </a:solidFill>
+          <a:ln w="12700">
+            <a:solidFill>
+              <a:srgbClr val="23233C"/>
+            </a:solidFill>
+          </a:ln>
+        </p:spPr>
+        <p:style>
+          <a:lnRef idx="1">
+            <a:schemeClr val="accent1"/>
+          </a:lnRef>
+          <a:fillRef idx="3">
+            <a:schemeClr val="accent1"/>
+          </a:fillRef>
+          <a:effectRef idx="2">
+            <a:schemeClr val="accent1"/>
+          </a:effectRef>
+          <a:fontRef idx="minor">
+            <a:schemeClr val="lt1"/>
+          </a:fontRef>
+        </p:style>
+        <p:txBody>
+          <a:bodyPr rtlCol="0" anchor="ctr"/>
+          <a:lstStyle/>
+          <a:p>
+            <a:pPr algn="ctr"/>
+          </a:p>
+        </p:txBody>
+      </p:sp>
+      <p:sp>
+        <p:nvSpPr>
+          <p:cNvPr id="14" name="Rectangle 13"/>
+          <p:cNvSpPr/>
+          <p:nvPr/>
+        </p:nvSpPr>
+        <p:spPr>
+          <a:xfrm>
+            <a:off x="6339535" y="4023360"/>
+            <a:ext cx="50800" cy="2011680"/>
+          </a:xfrm>
+          <a:prstGeom prst="rect">
+            <a:avLst/>
+          </a:prstGeom>
+          <a:solidFill>
+            <a:srgbClr val="7928CA"/>
+          </a:solidFill>
+          <a:ln>
+            <a:noFill/>
+          </a:ln>
+        </p:spPr>
+        <p:style>
+          <a:lnRef idx="1">
+            <a:schemeClr val="accent1"/>
+          </a:lnRef>
+          <a:fillRef idx="3">
+            <a:schemeClr val="accent1"/>
+          </a:fillRef>
+          <a:effectRef idx="2">
+            <a:schemeClr val="accent1"/>
+          </a:effectRef>
+          <a:fontRef idx="minor">
+            <a:schemeClr val="lt1"/>
+          </a:fontRef>
+        </p:style>
+        <p:txBody>
+          <a:bodyPr rtlCol="0" anchor="ctr"/>
+          <a:lstStyle/>
+          <a:p>
+            <a:pPr algn="ctr"/>
+          </a:p>
+        </p:txBody>
+      </p:sp>
+      <p:sp>
+        <p:nvSpPr>
+          <p:cNvPr id="15" name="TextBox 14"/>
+          <p:cNvSpPr txBox="1"/>
+          <p:nvPr/>
+        </p:nvSpPr>
+        <p:spPr>
+          <a:xfrm>
+            <a:off x="6568135" y="4206240"/>
+            <a:ext cx="4754880" cy="1645920"/>
+          </a:xfrm>
+          <a:prstGeom prst="rect">
+            <a:avLst/>
+          </a:prstGeom>
+          <a:noFill/>
+        </p:spPr>
+        <p:txBody>
+          <a:bodyPr wrap="square">
+            <a:spAutoFit/>
+          </a:bodyPr>
+          <a:lstStyle/>
           <a:p>
             <a:pPr>
-              <a:spcBef>
-                <a:spcPts val="1400"/>
-              </a:spcBef>
-              <a:defRPr sz="2000" b="1">
+              <a:spcAft>
+                <a:spcPts val="600"/>
+              </a:spcAft>
+              <a:defRPr sz="1800" b="1">
                 <a:solidFill>
                   <a:srgbClr val="00DFD8"/>
                 </a:solidFill>
@@ -3965,7 +5434,7 @@
               </a:defRPr>
             </a:pPr>
             <a:r>
-              <a:t>4. Weight Adjustments</a:t>
+              <a:t>4. Dynamic Weighting</a:t>
             </a:r>
           </a:p>
           <a:p>
@@ -3973,7 +5442,7 @@
               <a:spcBef>
                 <a:spcPts val="400"/>
               </a:spcBef>
-              <a:defRPr sz="1500">
+              <a:defRPr sz="1350">
                 <a:solidFill>
                   <a:srgbClr val="FFFFFF"/>
                 </a:solidFill>
@@ -4000,7 +5469,7 @@
     <p:bg>
       <p:bgPr>
         <a:solidFill>
-          <a:srgbClr val="0F0F1B"/>
+          <a:srgbClr val="0C0C14"/>
         </a:solidFill>
         <a:effectLst/>
       </p:bgPr>
@@ -4020,8 +5489,8 @@
         </p:nvSpPr>
         <p:spPr>
           <a:xfrm>
-            <a:off x="731520" y="457200"/>
-            <a:ext cx="10698480" cy="914400"/>
+            <a:off x="731520" y="365760"/>
+            <a:ext cx="10698480" cy="731520"/>
           </a:xfrm>
           <a:prstGeom prst="rect">
             <a:avLst/>
@@ -4035,7 +5504,7 @@
           <a:lstStyle/>
           <a:p>
             <a:pPr>
-              <a:defRPr sz="3600" b="1">
+              <a:defRPr sz="3200" b="1">
                 <a:solidFill>
                   <a:srgbClr val="00DFD8"/>
                 </a:solidFill>
@@ -4050,14 +5519,145 @@
       </p:sp>
       <p:sp>
         <p:nvSpPr>
-          <p:cNvPr id="3" name="TextBox 2"/>
+          <p:cNvPr id="3" name="Rectangle 2"/>
+          <p:cNvSpPr/>
+          <p:nvPr/>
+        </p:nvSpPr>
+        <p:spPr>
+          <a:xfrm>
+            <a:off x="731520" y="1097280"/>
+            <a:ext cx="10728655" cy="19050"/>
+          </a:xfrm>
+          <a:prstGeom prst="rect">
+            <a:avLst/>
+          </a:prstGeom>
+          <a:solidFill>
+            <a:srgbClr val="23233C"/>
+          </a:solidFill>
+          <a:ln>
+            <a:noFill/>
+          </a:ln>
+        </p:spPr>
+        <p:style>
+          <a:lnRef idx="1">
+            <a:schemeClr val="accent1"/>
+          </a:lnRef>
+          <a:fillRef idx="3">
+            <a:schemeClr val="accent1"/>
+          </a:fillRef>
+          <a:effectRef idx="2">
+            <a:schemeClr val="accent1"/>
+          </a:effectRef>
+          <a:fontRef idx="minor">
+            <a:schemeClr val="lt1"/>
+          </a:fontRef>
+        </p:style>
+        <p:txBody>
+          <a:bodyPr rtlCol="0" anchor="ctr"/>
+          <a:lstStyle/>
+          <a:p>
+            <a:pPr algn="ctr"/>
+          </a:p>
+        </p:txBody>
+      </p:sp>
+      <p:sp>
+        <p:nvSpPr>
+          <p:cNvPr id="4" name="Rectangle 3"/>
+          <p:cNvSpPr/>
+          <p:nvPr/>
+        </p:nvSpPr>
+        <p:spPr>
+          <a:xfrm>
+            <a:off x="731520" y="1645920"/>
+            <a:ext cx="3328416" cy="4389120"/>
+          </a:xfrm>
+          <a:prstGeom prst="rect">
+            <a:avLst/>
+          </a:prstGeom>
+          <a:solidFill>
+            <a:srgbClr val="161626"/>
+          </a:solidFill>
+          <a:ln w="12700">
+            <a:solidFill>
+              <a:srgbClr val="23233C"/>
+            </a:solidFill>
+          </a:ln>
+        </p:spPr>
+        <p:style>
+          <a:lnRef idx="1">
+            <a:schemeClr val="accent1"/>
+          </a:lnRef>
+          <a:fillRef idx="3">
+            <a:schemeClr val="accent1"/>
+          </a:fillRef>
+          <a:effectRef idx="2">
+            <a:schemeClr val="accent1"/>
+          </a:effectRef>
+          <a:fontRef idx="minor">
+            <a:schemeClr val="lt1"/>
+          </a:fontRef>
+        </p:style>
+        <p:txBody>
+          <a:bodyPr rtlCol="0" anchor="ctr"/>
+          <a:lstStyle/>
+          <a:p>
+            <a:pPr algn="ctr"/>
+          </a:p>
+        </p:txBody>
+      </p:sp>
+      <p:sp>
+        <p:nvSpPr>
+          <p:cNvPr id="5" name="Rectangle 4"/>
+          <p:cNvSpPr/>
+          <p:nvPr/>
+        </p:nvSpPr>
+        <p:spPr>
+          <a:xfrm>
+            <a:off x="731520" y="1645920"/>
+            <a:ext cx="3328416" cy="50800"/>
+          </a:xfrm>
+          <a:prstGeom prst="rect">
+            <a:avLst/>
+          </a:prstGeom>
+          <a:solidFill>
+            <a:srgbClr val="00DFD8"/>
+          </a:solidFill>
+          <a:ln>
+            <a:noFill/>
+          </a:ln>
+        </p:spPr>
+        <p:style>
+          <a:lnRef idx="1">
+            <a:schemeClr val="accent1"/>
+          </a:lnRef>
+          <a:fillRef idx="3">
+            <a:schemeClr val="accent1"/>
+          </a:fillRef>
+          <a:effectRef idx="2">
+            <a:schemeClr val="accent1"/>
+          </a:effectRef>
+          <a:fontRef idx="minor">
+            <a:schemeClr val="lt1"/>
+          </a:fontRef>
+        </p:style>
+        <p:txBody>
+          <a:bodyPr rtlCol="0" anchor="ctr"/>
+          <a:lstStyle/>
+          <a:p>
+            <a:pPr algn="ctr"/>
+          </a:p>
+        </p:txBody>
+      </p:sp>
+      <p:sp>
+        <p:nvSpPr>
+          <p:cNvPr id="6" name="TextBox 5"/>
           <p:cNvSpPr txBox="1"/>
           <p:nvPr/>
         </p:nvSpPr>
         <p:spPr>
           <a:xfrm>
-            <a:off x="731520" y="1645920"/>
-            <a:ext cx="10698480" cy="4572000"/>
+            <a:off x="914400" y="1920240"/>
+            <a:ext cx="2962656" cy="3931920"/>
           </a:xfrm>
           <a:prstGeom prst="rect">
             <a:avLst/>
@@ -4071,10 +5671,10 @@
           <a:lstStyle/>
           <a:p>
             <a:pPr>
-              <a:spcBef>
-                <a:spcPts val="1400"/>
-              </a:spcBef>
-              <a:defRPr sz="2000" b="1">
+              <a:spcAft>
+                <a:spcPts val="1200"/>
+              </a:spcAft>
+              <a:defRPr sz="1800" b="1">
                 <a:solidFill>
                   <a:srgbClr val="00DFD8"/>
                 </a:solidFill>
@@ -4090,7 +5690,7 @@
               <a:spcBef>
                 <a:spcPts val="400"/>
               </a:spcBef>
-              <a:defRPr sz="1500">
+              <a:defRPr sz="1350">
                 <a:solidFill>
                   <a:srgbClr val="FFFFFF"/>
                 </a:solidFill>
@@ -4101,12 +5701,123 @@
               <a:t>Uses local SentenceTransformers ('all-MiniLM-L6-v2') to compute 384-dimensional dense vectors locally to secure high performance.</a:t>
             </a:r>
           </a:p>
+        </p:txBody>
+      </p:sp>
+      <p:sp>
+        <p:nvSpPr>
+          <p:cNvPr id="7" name="Rectangle 6"/>
+          <p:cNvSpPr/>
+          <p:nvPr/>
+        </p:nvSpPr>
+        <p:spPr>
+          <a:xfrm>
+            <a:off x="4425696" y="1645920"/>
+            <a:ext cx="3328416" cy="4389120"/>
+          </a:xfrm>
+          <a:prstGeom prst="rect">
+            <a:avLst/>
+          </a:prstGeom>
+          <a:solidFill>
+            <a:srgbClr val="161626"/>
+          </a:solidFill>
+          <a:ln w="12700">
+            <a:solidFill>
+              <a:srgbClr val="23233C"/>
+            </a:solidFill>
+          </a:ln>
+        </p:spPr>
+        <p:style>
+          <a:lnRef idx="1">
+            <a:schemeClr val="accent1"/>
+          </a:lnRef>
+          <a:fillRef idx="3">
+            <a:schemeClr val="accent1"/>
+          </a:fillRef>
+          <a:effectRef idx="2">
+            <a:schemeClr val="accent1"/>
+          </a:effectRef>
+          <a:fontRef idx="minor">
+            <a:schemeClr val="lt1"/>
+          </a:fontRef>
+        </p:style>
+        <p:txBody>
+          <a:bodyPr rtlCol="0" anchor="ctr"/>
+          <a:lstStyle/>
+          <a:p>
+            <a:pPr algn="ctr"/>
+          </a:p>
+        </p:txBody>
+      </p:sp>
+      <p:sp>
+        <p:nvSpPr>
+          <p:cNvPr id="8" name="Rectangle 7"/>
+          <p:cNvSpPr/>
+          <p:nvPr/>
+        </p:nvSpPr>
+        <p:spPr>
+          <a:xfrm>
+            <a:off x="4425696" y="1645920"/>
+            <a:ext cx="3328416" cy="50800"/>
+          </a:xfrm>
+          <a:prstGeom prst="rect">
+            <a:avLst/>
+          </a:prstGeom>
+          <a:solidFill>
+            <a:srgbClr val="00DFD8"/>
+          </a:solidFill>
+          <a:ln>
+            <a:noFill/>
+          </a:ln>
+        </p:spPr>
+        <p:style>
+          <a:lnRef idx="1">
+            <a:schemeClr val="accent1"/>
+          </a:lnRef>
+          <a:fillRef idx="3">
+            <a:schemeClr val="accent1"/>
+          </a:fillRef>
+          <a:effectRef idx="2">
+            <a:schemeClr val="accent1"/>
+          </a:effectRef>
+          <a:fontRef idx="minor">
+            <a:schemeClr val="lt1"/>
+          </a:fontRef>
+        </p:style>
+        <p:txBody>
+          <a:bodyPr rtlCol="0" anchor="ctr"/>
+          <a:lstStyle/>
+          <a:p>
+            <a:pPr algn="ctr"/>
+          </a:p>
+        </p:txBody>
+      </p:sp>
+      <p:sp>
+        <p:nvSpPr>
+          <p:cNvPr id="9" name="TextBox 8"/>
+          <p:cNvSpPr txBox="1"/>
+          <p:nvPr/>
+        </p:nvSpPr>
+        <p:spPr>
+          <a:xfrm>
+            <a:off x="4608576" y="1920240"/>
+            <a:ext cx="2962656" cy="3931920"/>
+          </a:xfrm>
+          <a:prstGeom prst="rect">
+            <a:avLst/>
+          </a:prstGeom>
+          <a:noFill/>
+        </p:spPr>
+        <p:txBody>
+          <a:bodyPr wrap="square">
+            <a:spAutoFit/>
+          </a:bodyPr>
+          <a:lstStyle/>
           <a:p>
             <a:pPr>
-              <a:spcBef>
-                <a:spcPts val="1400"/>
-              </a:spcBef>
-              <a:defRPr sz="2000" b="1">
+              <a:spcAft>
+                <a:spcPts val="1200"/>
+              </a:spcAft>
+              <a:defRPr sz="1800" b="1">
                 <a:solidFill>
                   <a:srgbClr val="00DFD8"/>
                 </a:solidFill>
@@ -4122,7 +5833,7 @@
               <a:spcBef>
                 <a:spcPts val="400"/>
               </a:spcBef>
-              <a:defRPr sz="1500">
+              <a:defRPr sz="1350">
                 <a:solidFill>
                   <a:srgbClr val="FFFFFF"/>
                 </a:solidFill>
@@ -4133,12 +5844,123 @@
               <a:t>If remote servers or libraries are missing, the system uses local NumPy vector calculations and an in-memory cache to ensure zero-downtime evaluation.</a:t>
             </a:r>
           </a:p>
+        </p:txBody>
+      </p:sp>
+      <p:sp>
+        <p:nvSpPr>
+          <p:cNvPr id="10" name="Rectangle 9"/>
+          <p:cNvSpPr/>
+          <p:nvPr/>
+        </p:nvSpPr>
+        <p:spPr>
+          <a:xfrm>
+            <a:off x="8119872" y="1645920"/>
+            <a:ext cx="3328416" cy="4389120"/>
+          </a:xfrm>
+          <a:prstGeom prst="rect">
+            <a:avLst/>
+          </a:prstGeom>
+          <a:solidFill>
+            <a:srgbClr val="161626"/>
+          </a:solidFill>
+          <a:ln w="12700">
+            <a:solidFill>
+              <a:srgbClr val="23233C"/>
+            </a:solidFill>
+          </a:ln>
+        </p:spPr>
+        <p:style>
+          <a:lnRef idx="1">
+            <a:schemeClr val="accent1"/>
+          </a:lnRef>
+          <a:fillRef idx="3">
+            <a:schemeClr val="accent1"/>
+          </a:fillRef>
+          <a:effectRef idx="2">
+            <a:schemeClr val="accent1"/>
+          </a:effectRef>
+          <a:fontRef idx="minor">
+            <a:schemeClr val="lt1"/>
+          </a:fontRef>
+        </p:style>
+        <p:txBody>
+          <a:bodyPr rtlCol="0" anchor="ctr"/>
+          <a:lstStyle/>
+          <a:p>
+            <a:pPr algn="ctr"/>
+          </a:p>
+        </p:txBody>
+      </p:sp>
+      <p:sp>
+        <p:nvSpPr>
+          <p:cNvPr id="11" name="Rectangle 10"/>
+          <p:cNvSpPr/>
+          <p:nvPr/>
+        </p:nvSpPr>
+        <p:spPr>
+          <a:xfrm>
+            <a:off x="8119872" y="1645920"/>
+            <a:ext cx="3328416" cy="50800"/>
+          </a:xfrm>
+          <a:prstGeom prst="rect">
+            <a:avLst/>
+          </a:prstGeom>
+          <a:solidFill>
+            <a:srgbClr val="00DFD8"/>
+          </a:solidFill>
+          <a:ln>
+            <a:noFill/>
+          </a:ln>
+        </p:spPr>
+        <p:style>
+          <a:lnRef idx="1">
+            <a:schemeClr val="accent1"/>
+          </a:lnRef>
+          <a:fillRef idx="3">
+            <a:schemeClr val="accent1"/>
+          </a:fillRef>
+          <a:effectRef idx="2">
+            <a:schemeClr val="accent1"/>
+          </a:effectRef>
+          <a:fontRef idx="minor">
+            <a:schemeClr val="lt1"/>
+          </a:fontRef>
+        </p:style>
+        <p:txBody>
+          <a:bodyPr rtlCol="0" anchor="ctr"/>
+          <a:lstStyle/>
+          <a:p>
+            <a:pPr algn="ctr"/>
+          </a:p>
+        </p:txBody>
+      </p:sp>
+      <p:sp>
+        <p:nvSpPr>
+          <p:cNvPr id="12" name="TextBox 11"/>
+          <p:cNvSpPr txBox="1"/>
+          <p:nvPr/>
+        </p:nvSpPr>
+        <p:spPr>
+          <a:xfrm>
+            <a:off x="8302752" y="1920240"/>
+            <a:ext cx="2962656" cy="3931920"/>
+          </a:xfrm>
+          <a:prstGeom prst="rect">
+            <a:avLst/>
+          </a:prstGeom>
+          <a:noFill/>
+        </p:spPr>
+        <p:txBody>
+          <a:bodyPr wrap="square">
+            <a:spAutoFit/>
+          </a:bodyPr>
+          <a:lstStyle/>
           <a:p>
             <a:pPr>
-              <a:spcBef>
-                <a:spcPts val="1400"/>
-              </a:spcBef>
-              <a:defRPr sz="2000" b="1">
+              <a:spcAft>
+                <a:spcPts val="1200"/>
+              </a:spcAft>
+              <a:defRPr sz="1800" b="1">
                 <a:solidFill>
                   <a:srgbClr val="00DFD8"/>
                 </a:solidFill>
@@ -4146,7 +5968,7 @@
               </a:defRPr>
             </a:pPr>
             <a:r>
-              <a:t>Dynamic Shortlist Customization</a:t>
+              <a:t>Dynamic Customization</a:t>
             </a:r>
           </a:p>
           <a:p>
@@ -4154,7 +5976,7 @@
               <a:spcBef>
                 <a:spcPts val="400"/>
               </a:spcBef>
-              <a:defRPr sz="1500">
+              <a:defRPr sz="1350">
                 <a:solidFill>
                   <a:srgbClr val="FFFFFF"/>
                 </a:solidFill>
@@ -4181,7 +6003,7 @@
     <p:bg>
       <p:bgPr>
         <a:solidFill>
-          <a:srgbClr val="0F0F1B"/>
+          <a:srgbClr val="0C0C14"/>
         </a:solidFill>
         <a:effectLst/>
       </p:bgPr>
@@ -4201,8 +6023,8 @@
         </p:nvSpPr>
         <p:spPr>
           <a:xfrm>
-            <a:off x="731520" y="457200"/>
-            <a:ext cx="10698480" cy="914400"/>
+            <a:off x="731520" y="365760"/>
+            <a:ext cx="10698480" cy="731520"/>
           </a:xfrm>
           <a:prstGeom prst="rect">
             <a:avLst/>
@@ -4216,7 +6038,7 @@
           <a:lstStyle/>
           <a:p>
             <a:pPr>
-              <a:defRPr sz="3600" b="1">
+              <a:defRPr sz="3200" b="1">
                 <a:solidFill>
                   <a:srgbClr val="00DFD8"/>
                 </a:solidFill>
@@ -4231,14 +6053,145 @@
       </p:sp>
       <p:sp>
         <p:nvSpPr>
-          <p:cNvPr id="3" name="TextBox 2"/>
+          <p:cNvPr id="3" name="Rectangle 2"/>
+          <p:cNvSpPr/>
+          <p:nvPr/>
+        </p:nvSpPr>
+        <p:spPr>
+          <a:xfrm>
+            <a:off x="731520" y="1097280"/>
+            <a:ext cx="10728655" cy="19050"/>
+          </a:xfrm>
+          <a:prstGeom prst="rect">
+            <a:avLst/>
+          </a:prstGeom>
+          <a:solidFill>
+            <a:srgbClr val="23233C"/>
+          </a:solidFill>
+          <a:ln>
+            <a:noFill/>
+          </a:ln>
+        </p:spPr>
+        <p:style>
+          <a:lnRef idx="1">
+            <a:schemeClr val="accent1"/>
+          </a:lnRef>
+          <a:fillRef idx="3">
+            <a:schemeClr val="accent1"/>
+          </a:fillRef>
+          <a:effectRef idx="2">
+            <a:schemeClr val="accent1"/>
+          </a:effectRef>
+          <a:fontRef idx="minor">
+            <a:schemeClr val="lt1"/>
+          </a:fontRef>
+        </p:style>
+        <p:txBody>
+          <a:bodyPr rtlCol="0" anchor="ctr"/>
+          <a:lstStyle/>
+          <a:p>
+            <a:pPr algn="ctr"/>
+          </a:p>
+        </p:txBody>
+      </p:sp>
+      <p:sp>
+        <p:nvSpPr>
+          <p:cNvPr id="4" name="Rectangle 3"/>
+          <p:cNvSpPr/>
+          <p:nvPr/>
+        </p:nvSpPr>
+        <p:spPr>
+          <a:xfrm>
+            <a:off x="731520" y="1645920"/>
+            <a:ext cx="3328416" cy="4389120"/>
+          </a:xfrm>
+          <a:prstGeom prst="rect">
+            <a:avLst/>
+          </a:prstGeom>
+          <a:solidFill>
+            <a:srgbClr val="161626"/>
+          </a:solidFill>
+          <a:ln w="12700">
+            <a:solidFill>
+              <a:srgbClr val="23233C"/>
+            </a:solidFill>
+          </a:ln>
+        </p:spPr>
+        <p:style>
+          <a:lnRef idx="1">
+            <a:schemeClr val="accent1"/>
+          </a:lnRef>
+          <a:fillRef idx="3">
+            <a:schemeClr val="accent1"/>
+          </a:fillRef>
+          <a:effectRef idx="2">
+            <a:schemeClr val="accent1"/>
+          </a:effectRef>
+          <a:fontRef idx="minor">
+            <a:schemeClr val="lt1"/>
+          </a:fontRef>
+        </p:style>
+        <p:txBody>
+          <a:bodyPr rtlCol="0" anchor="ctr"/>
+          <a:lstStyle/>
+          <a:p>
+            <a:pPr algn="ctr"/>
+          </a:p>
+        </p:txBody>
+      </p:sp>
+      <p:sp>
+        <p:nvSpPr>
+          <p:cNvPr id="5" name="Rectangle 4"/>
+          <p:cNvSpPr/>
+          <p:nvPr/>
+        </p:nvSpPr>
+        <p:spPr>
+          <a:xfrm>
+            <a:off x="731520" y="1645920"/>
+            <a:ext cx="3328416" cy="50800"/>
+          </a:xfrm>
+          <a:prstGeom prst="rect">
+            <a:avLst/>
+          </a:prstGeom>
+          <a:solidFill>
+            <a:srgbClr val="00DFD8"/>
+          </a:solidFill>
+          <a:ln>
+            <a:noFill/>
+          </a:ln>
+        </p:spPr>
+        <p:style>
+          <a:lnRef idx="1">
+            <a:schemeClr val="accent1"/>
+          </a:lnRef>
+          <a:fillRef idx="3">
+            <a:schemeClr val="accent1"/>
+          </a:fillRef>
+          <a:effectRef idx="2">
+            <a:schemeClr val="accent1"/>
+          </a:effectRef>
+          <a:fontRef idx="minor">
+            <a:schemeClr val="lt1"/>
+          </a:fontRef>
+        </p:style>
+        <p:txBody>
+          <a:bodyPr rtlCol="0" anchor="ctr"/>
+          <a:lstStyle/>
+          <a:p>
+            <a:pPr algn="ctr"/>
+          </a:p>
+        </p:txBody>
+      </p:sp>
+      <p:sp>
+        <p:nvSpPr>
+          <p:cNvPr id="6" name="TextBox 5"/>
           <p:cNvSpPr txBox="1"/>
           <p:nvPr/>
         </p:nvSpPr>
         <p:spPr>
           <a:xfrm>
-            <a:off x="731520" y="1645920"/>
-            <a:ext cx="10698480" cy="4572000"/>
+            <a:off x="914400" y="1920240"/>
+            <a:ext cx="2962656" cy="3931920"/>
           </a:xfrm>
           <a:prstGeom prst="rect">
             <a:avLst/>
@@ -4252,10 +6205,10 @@
           <a:lstStyle/>
           <a:p>
             <a:pPr>
-              <a:spcBef>
-                <a:spcPts val="1400"/>
-              </a:spcBef>
-              <a:defRPr sz="2000" b="1">
+              <a:spcAft>
+                <a:spcPts val="1200"/>
+              </a:spcAft>
+              <a:defRPr sz="1800" b="1">
                 <a:solidFill>
                   <a:srgbClr val="00DFD8"/>
                 </a:solidFill>
@@ -4271,7 +6224,7 @@
               <a:spcBef>
                 <a:spcPts val="400"/>
               </a:spcBef>
-              <a:defRPr sz="1500">
+              <a:defRPr sz="1350">
                 <a:solidFill>
                   <a:srgbClr val="FFFFFF"/>
                 </a:solidFill>
@@ -4282,12 +6235,123 @@
               <a:t>Gemini 2.0 Flash performs deep text analysis of candidates' career milestones, project details, and technical expertise to assign realistic fit scores.</a:t>
             </a:r>
           </a:p>
+        </p:txBody>
+      </p:sp>
+      <p:sp>
+        <p:nvSpPr>
+          <p:cNvPr id="7" name="Rectangle 6"/>
+          <p:cNvSpPr/>
+          <p:nvPr/>
+        </p:nvSpPr>
+        <p:spPr>
+          <a:xfrm>
+            <a:off x="4425696" y="1645920"/>
+            <a:ext cx="3328416" cy="4389120"/>
+          </a:xfrm>
+          <a:prstGeom prst="rect">
+            <a:avLst/>
+          </a:prstGeom>
+          <a:solidFill>
+            <a:srgbClr val="161626"/>
+          </a:solidFill>
+          <a:ln w="12700">
+            <a:solidFill>
+              <a:srgbClr val="23233C"/>
+            </a:solidFill>
+          </a:ln>
+        </p:spPr>
+        <p:style>
+          <a:lnRef idx="1">
+            <a:schemeClr val="accent1"/>
+          </a:lnRef>
+          <a:fillRef idx="3">
+            <a:schemeClr val="accent1"/>
+          </a:fillRef>
+          <a:effectRef idx="2">
+            <a:schemeClr val="accent1"/>
+          </a:effectRef>
+          <a:fontRef idx="minor">
+            <a:schemeClr val="lt1"/>
+          </a:fontRef>
+        </p:style>
+        <p:txBody>
+          <a:bodyPr rtlCol="0" anchor="ctr"/>
+          <a:lstStyle/>
+          <a:p>
+            <a:pPr algn="ctr"/>
+          </a:p>
+        </p:txBody>
+      </p:sp>
+      <p:sp>
+        <p:nvSpPr>
+          <p:cNvPr id="8" name="Rectangle 7"/>
+          <p:cNvSpPr/>
+          <p:nvPr/>
+        </p:nvSpPr>
+        <p:spPr>
+          <a:xfrm>
+            <a:off x="4425696" y="1645920"/>
+            <a:ext cx="3328416" cy="50800"/>
+          </a:xfrm>
+          <a:prstGeom prst="rect">
+            <a:avLst/>
+          </a:prstGeom>
+          <a:solidFill>
+            <a:srgbClr val="00DFD8"/>
+          </a:solidFill>
+          <a:ln>
+            <a:noFill/>
+          </a:ln>
+        </p:spPr>
+        <p:style>
+          <a:lnRef idx="1">
+            <a:schemeClr val="accent1"/>
+          </a:lnRef>
+          <a:fillRef idx="3">
+            <a:schemeClr val="accent1"/>
+          </a:fillRef>
+          <a:effectRef idx="2">
+            <a:schemeClr val="accent1"/>
+          </a:effectRef>
+          <a:fontRef idx="minor">
+            <a:schemeClr val="lt1"/>
+          </a:fontRef>
+        </p:style>
+        <p:txBody>
+          <a:bodyPr rtlCol="0" anchor="ctr"/>
+          <a:lstStyle/>
+          <a:p>
+            <a:pPr algn="ctr"/>
+          </a:p>
+        </p:txBody>
+      </p:sp>
+      <p:sp>
+        <p:nvSpPr>
+          <p:cNvPr id="9" name="TextBox 8"/>
+          <p:cNvSpPr txBox="1"/>
+          <p:nvPr/>
+        </p:nvSpPr>
+        <p:spPr>
+          <a:xfrm>
+            <a:off x="4608576" y="1920240"/>
+            <a:ext cx="2962656" cy="3931920"/>
+          </a:xfrm>
+          <a:prstGeom prst="rect">
+            <a:avLst/>
+          </a:prstGeom>
+          <a:noFill/>
+        </p:spPr>
+        <p:txBody>
+          <a:bodyPr wrap="square">
+            <a:spAutoFit/>
+          </a:bodyPr>
+          <a:lstStyle/>
           <a:p>
             <a:pPr>
-              <a:spcBef>
-                <a:spcPts val="1400"/>
-              </a:spcBef>
-              <a:defRPr sz="2000" b="1">
+              <a:spcAft>
+                <a:spcPts val="1200"/>
+              </a:spcAft>
+              <a:defRPr sz="1800" b="1">
                 <a:solidFill>
                   <a:srgbClr val="00DFD8"/>
                 </a:solidFill>
@@ -4295,7 +6359,7 @@
               </a:defRPr>
             </a:pPr>
             <a:r>
-              <a:t>Constructive Feedback Loop</a:t>
+              <a:t>Constructive Feedback</a:t>
             </a:r>
           </a:p>
           <a:p>
@@ -4303,7 +6367,7 @@
               <a:spcBef>
                 <a:spcPts val="400"/>
               </a:spcBef>
-              <a:defRPr sz="1500">
+              <a:defRPr sz="1350">
                 <a:solidFill>
                   <a:srgbClr val="FFFFFF"/>
                 </a:solidFill>
@@ -4314,12 +6378,123 @@
               <a:t>Automatically drafts personalized emails, including structured outreach invites for top matches and customized feedback with learning resources for rejected profiles.</a:t>
             </a:r>
           </a:p>
+        </p:txBody>
+      </p:sp>
+      <p:sp>
+        <p:nvSpPr>
+          <p:cNvPr id="10" name="Rectangle 9"/>
+          <p:cNvSpPr/>
+          <p:nvPr/>
+        </p:nvSpPr>
+        <p:spPr>
+          <a:xfrm>
+            <a:off x="8119872" y="1645920"/>
+            <a:ext cx="3328416" cy="4389120"/>
+          </a:xfrm>
+          <a:prstGeom prst="rect">
+            <a:avLst/>
+          </a:prstGeom>
+          <a:solidFill>
+            <a:srgbClr val="161626"/>
+          </a:solidFill>
+          <a:ln w="12700">
+            <a:solidFill>
+              <a:srgbClr val="23233C"/>
+            </a:solidFill>
+          </a:ln>
+        </p:spPr>
+        <p:style>
+          <a:lnRef idx="1">
+            <a:schemeClr val="accent1"/>
+          </a:lnRef>
+          <a:fillRef idx="3">
+            <a:schemeClr val="accent1"/>
+          </a:fillRef>
+          <a:effectRef idx="2">
+            <a:schemeClr val="accent1"/>
+          </a:effectRef>
+          <a:fontRef idx="minor">
+            <a:schemeClr val="lt1"/>
+          </a:fontRef>
+        </p:style>
+        <p:txBody>
+          <a:bodyPr rtlCol="0" anchor="ctr"/>
+          <a:lstStyle/>
+          <a:p>
+            <a:pPr algn="ctr"/>
+          </a:p>
+        </p:txBody>
+      </p:sp>
+      <p:sp>
+        <p:nvSpPr>
+          <p:cNvPr id="11" name="Rectangle 10"/>
+          <p:cNvSpPr/>
+          <p:nvPr/>
+        </p:nvSpPr>
+        <p:spPr>
+          <a:xfrm>
+            <a:off x="8119872" y="1645920"/>
+            <a:ext cx="3328416" cy="50800"/>
+          </a:xfrm>
+          <a:prstGeom prst="rect">
+            <a:avLst/>
+          </a:prstGeom>
+          <a:solidFill>
+            <a:srgbClr val="00DFD8"/>
+          </a:solidFill>
+          <a:ln>
+            <a:noFill/>
+          </a:ln>
+        </p:spPr>
+        <p:style>
+          <a:lnRef idx="1">
+            <a:schemeClr val="accent1"/>
+          </a:lnRef>
+          <a:fillRef idx="3">
+            <a:schemeClr val="accent1"/>
+          </a:fillRef>
+          <a:effectRef idx="2">
+            <a:schemeClr val="accent1"/>
+          </a:effectRef>
+          <a:fontRef idx="minor">
+            <a:schemeClr val="lt1"/>
+          </a:fontRef>
+        </p:style>
+        <p:txBody>
+          <a:bodyPr rtlCol="0" anchor="ctr"/>
+          <a:lstStyle/>
+          <a:p>
+            <a:pPr algn="ctr"/>
+          </a:p>
+        </p:txBody>
+      </p:sp>
+      <p:sp>
+        <p:nvSpPr>
+          <p:cNvPr id="12" name="TextBox 11"/>
+          <p:cNvSpPr txBox="1"/>
+          <p:nvPr/>
+        </p:nvSpPr>
+        <p:spPr>
+          <a:xfrm>
+            <a:off x="8302752" y="1920240"/>
+            <a:ext cx="2962656" cy="3931920"/>
+          </a:xfrm>
+          <a:prstGeom prst="rect">
+            <a:avLst/>
+          </a:prstGeom>
+          <a:noFill/>
+        </p:spPr>
+        <p:txBody>
+          <a:bodyPr wrap="square">
+            <a:spAutoFit/>
+          </a:bodyPr>
+          <a:lstStyle/>
           <a:p>
             <a:pPr>
-              <a:spcBef>
-                <a:spcPts val="1400"/>
-              </a:spcBef>
-              <a:defRPr sz="2000" b="1">
+              <a:spcAft>
+                <a:spcPts val="1200"/>
+              </a:spcAft>
+              <a:defRPr sz="1800" b="1">
                 <a:solidFill>
                   <a:srgbClr val="00DFD8"/>
                 </a:solidFill>
@@ -4335,7 +6510,7 @@
               <a:spcBef>
                 <a:spcPts val="400"/>
               </a:spcBef>
-              <a:defRPr sz="1500">
+              <a:defRPr sz="1350">
                 <a:solidFill>
                   <a:srgbClr val="FFFFFF"/>
                 </a:solidFill>
@@ -4362,7 +6537,7 @@
     <p:bg>
       <p:bgPr>
         <a:solidFill>
-          <a:srgbClr val="0F0F1B"/>
+          <a:srgbClr val="0C0C14"/>
         </a:solidFill>
         <a:effectLst/>
       </p:bgPr>
@@ -4382,8 +6557,8 @@
         </p:nvSpPr>
         <p:spPr>
           <a:xfrm>
-            <a:off x="731520" y="457200"/>
-            <a:ext cx="10698480" cy="914400"/>
+            <a:off x="731520" y="365760"/>
+            <a:ext cx="10698480" cy="731520"/>
           </a:xfrm>
           <a:prstGeom prst="rect">
             <a:avLst/>
@@ -4397,7 +6572,7 @@
           <a:lstStyle/>
           <a:p>
             <a:pPr>
-              <a:defRPr sz="3600" b="1">
+              <a:defRPr sz="3200" b="1">
                 <a:solidFill>
                   <a:srgbClr val="00DFD8"/>
                 </a:solidFill>
@@ -4412,14 +6587,145 @@
       </p:sp>
       <p:sp>
         <p:nvSpPr>
-          <p:cNvPr id="3" name="TextBox 2"/>
+          <p:cNvPr id="3" name="Rectangle 2"/>
+          <p:cNvSpPr/>
+          <p:nvPr/>
+        </p:nvSpPr>
+        <p:spPr>
+          <a:xfrm>
+            <a:off x="731520" y="1097280"/>
+            <a:ext cx="10728655" cy="19050"/>
+          </a:xfrm>
+          <a:prstGeom prst="rect">
+            <a:avLst/>
+          </a:prstGeom>
+          <a:solidFill>
+            <a:srgbClr val="23233C"/>
+          </a:solidFill>
+          <a:ln>
+            <a:noFill/>
+          </a:ln>
+        </p:spPr>
+        <p:style>
+          <a:lnRef idx="1">
+            <a:schemeClr val="accent1"/>
+          </a:lnRef>
+          <a:fillRef idx="3">
+            <a:schemeClr val="accent1"/>
+          </a:fillRef>
+          <a:effectRef idx="2">
+            <a:schemeClr val="accent1"/>
+          </a:effectRef>
+          <a:fontRef idx="minor">
+            <a:schemeClr val="lt1"/>
+          </a:fontRef>
+        </p:style>
+        <p:txBody>
+          <a:bodyPr rtlCol="0" anchor="ctr"/>
+          <a:lstStyle/>
+          <a:p>
+            <a:pPr algn="ctr"/>
+          </a:p>
+        </p:txBody>
+      </p:sp>
+      <p:sp>
+        <p:nvSpPr>
+          <p:cNvPr id="4" name="Rectangle 3"/>
+          <p:cNvSpPr/>
+          <p:nvPr/>
+        </p:nvSpPr>
+        <p:spPr>
+          <a:xfrm>
+            <a:off x="731520" y="1645920"/>
+            <a:ext cx="3328416" cy="4389120"/>
+          </a:xfrm>
+          <a:prstGeom prst="rect">
+            <a:avLst/>
+          </a:prstGeom>
+          <a:solidFill>
+            <a:srgbClr val="161626"/>
+          </a:solidFill>
+          <a:ln w="12700">
+            <a:solidFill>
+              <a:srgbClr val="23233C"/>
+            </a:solidFill>
+          </a:ln>
+        </p:spPr>
+        <p:style>
+          <a:lnRef idx="1">
+            <a:schemeClr val="accent1"/>
+          </a:lnRef>
+          <a:fillRef idx="3">
+            <a:schemeClr val="accent1"/>
+          </a:fillRef>
+          <a:effectRef idx="2">
+            <a:schemeClr val="accent1"/>
+          </a:effectRef>
+          <a:fontRef idx="minor">
+            <a:schemeClr val="lt1"/>
+          </a:fontRef>
+        </p:style>
+        <p:txBody>
+          <a:bodyPr rtlCol="0" anchor="ctr"/>
+          <a:lstStyle/>
+          <a:p>
+            <a:pPr algn="ctr"/>
+          </a:p>
+        </p:txBody>
+      </p:sp>
+      <p:sp>
+        <p:nvSpPr>
+          <p:cNvPr id="5" name="Rectangle 4"/>
+          <p:cNvSpPr/>
+          <p:nvPr/>
+        </p:nvSpPr>
+        <p:spPr>
+          <a:xfrm>
+            <a:off x="731520" y="1645920"/>
+            <a:ext cx="3328416" cy="50800"/>
+          </a:xfrm>
+          <a:prstGeom prst="rect">
+            <a:avLst/>
+          </a:prstGeom>
+          <a:solidFill>
+            <a:srgbClr val="00DFD8"/>
+          </a:solidFill>
+          <a:ln>
+            <a:noFill/>
+          </a:ln>
+        </p:spPr>
+        <p:style>
+          <a:lnRef idx="1">
+            <a:schemeClr val="accent1"/>
+          </a:lnRef>
+          <a:fillRef idx="3">
+            <a:schemeClr val="accent1"/>
+          </a:fillRef>
+          <a:effectRef idx="2">
+            <a:schemeClr val="accent1"/>
+          </a:effectRef>
+          <a:fontRef idx="minor">
+            <a:schemeClr val="lt1"/>
+          </a:fontRef>
+        </p:style>
+        <p:txBody>
+          <a:bodyPr rtlCol="0" anchor="ctr"/>
+          <a:lstStyle/>
+          <a:p>
+            <a:pPr algn="ctr"/>
+          </a:p>
+        </p:txBody>
+      </p:sp>
+      <p:sp>
+        <p:nvSpPr>
+          <p:cNvPr id="6" name="TextBox 5"/>
           <p:cNvSpPr txBox="1"/>
           <p:nvPr/>
         </p:nvSpPr>
         <p:spPr>
           <a:xfrm>
-            <a:off x="731520" y="1645920"/>
-            <a:ext cx="10698480" cy="4572000"/>
+            <a:off x="914400" y="1920240"/>
+            <a:ext cx="2962656" cy="3931920"/>
           </a:xfrm>
           <a:prstGeom prst="rect">
             <a:avLst/>
@@ -4433,10 +6739,10 @@
           <a:lstStyle/>
           <a:p>
             <a:pPr>
-              <a:spcBef>
-                <a:spcPts val="1400"/>
-              </a:spcBef>
-              <a:defRPr sz="2000" b="1">
+              <a:spcAft>
+                <a:spcPts val="1200"/>
+              </a:spcAft>
+              <a:defRPr sz="1800" b="1">
                 <a:solidFill>
                   <a:srgbClr val="00DFD8"/>
                 </a:solidFill>
@@ -4444,7 +6750,7 @@
               </a:defRPr>
             </a:pPr>
             <a:r>
-              <a:t>WebRTC Biometrics Simulation</a:t>
+              <a:t>Biometrics Simulation</a:t>
             </a:r>
           </a:p>
           <a:p>
@@ -4452,7 +6758,7 @@
               <a:spcBef>
                 <a:spcPts val="400"/>
               </a:spcBef>
-              <a:defRPr sz="1500">
+              <a:defRPr sz="1350">
                 <a:solidFill>
                   <a:srgbClr val="FFFFFF"/>
                 </a:solidFill>
@@ -4463,12 +6769,123 @@
               <a:t>Local camera feed is rendered inside the chat portal with a live face landmark canvas to simulate focus tracking.</a:t>
             </a:r>
           </a:p>
+        </p:txBody>
+      </p:sp>
+      <p:sp>
+        <p:nvSpPr>
+          <p:cNvPr id="7" name="Rectangle 6"/>
+          <p:cNvSpPr/>
+          <p:nvPr/>
+        </p:nvSpPr>
+        <p:spPr>
+          <a:xfrm>
+            <a:off x="4425696" y="1645920"/>
+            <a:ext cx="3328416" cy="4389120"/>
+          </a:xfrm>
+          <a:prstGeom prst="rect">
+            <a:avLst/>
+          </a:prstGeom>
+          <a:solidFill>
+            <a:srgbClr val="161626"/>
+          </a:solidFill>
+          <a:ln w="12700">
+            <a:solidFill>
+              <a:srgbClr val="23233C"/>
+            </a:solidFill>
+          </a:ln>
+        </p:spPr>
+        <p:style>
+          <a:lnRef idx="1">
+            <a:schemeClr val="accent1"/>
+          </a:lnRef>
+          <a:fillRef idx="3">
+            <a:schemeClr val="accent1"/>
+          </a:fillRef>
+          <a:effectRef idx="2">
+            <a:schemeClr val="accent1"/>
+          </a:effectRef>
+          <a:fontRef idx="minor">
+            <a:schemeClr val="lt1"/>
+          </a:fontRef>
+        </p:style>
+        <p:txBody>
+          <a:bodyPr rtlCol="0" anchor="ctr"/>
+          <a:lstStyle/>
+          <a:p>
+            <a:pPr algn="ctr"/>
+          </a:p>
+        </p:txBody>
+      </p:sp>
+      <p:sp>
+        <p:nvSpPr>
+          <p:cNvPr id="8" name="Rectangle 7"/>
+          <p:cNvSpPr/>
+          <p:nvPr/>
+        </p:nvSpPr>
+        <p:spPr>
+          <a:xfrm>
+            <a:off x="4425696" y="1645920"/>
+            <a:ext cx="3328416" cy="50800"/>
+          </a:xfrm>
+          <a:prstGeom prst="rect">
+            <a:avLst/>
+          </a:prstGeom>
+          <a:solidFill>
+            <a:srgbClr val="00DFD8"/>
+          </a:solidFill>
+          <a:ln>
+            <a:noFill/>
+          </a:ln>
+        </p:spPr>
+        <p:style>
+          <a:lnRef idx="1">
+            <a:schemeClr val="accent1"/>
+          </a:lnRef>
+          <a:fillRef idx="3">
+            <a:schemeClr val="accent1"/>
+          </a:fillRef>
+          <a:effectRef idx="2">
+            <a:schemeClr val="accent1"/>
+          </a:effectRef>
+          <a:fontRef idx="minor">
+            <a:schemeClr val="lt1"/>
+          </a:fontRef>
+        </p:style>
+        <p:txBody>
+          <a:bodyPr rtlCol="0" anchor="ctr"/>
+          <a:lstStyle/>
+          <a:p>
+            <a:pPr algn="ctr"/>
+          </a:p>
+        </p:txBody>
+      </p:sp>
+      <p:sp>
+        <p:nvSpPr>
+          <p:cNvPr id="9" name="TextBox 8"/>
+          <p:cNvSpPr txBox="1"/>
+          <p:nvPr/>
+        </p:nvSpPr>
+        <p:spPr>
+          <a:xfrm>
+            <a:off x="4608576" y="1920240"/>
+            <a:ext cx="2962656" cy="3931920"/>
+          </a:xfrm>
+          <a:prstGeom prst="rect">
+            <a:avLst/>
+          </a:prstGeom>
+          <a:noFill/>
+        </p:spPr>
+        <p:txBody>
+          <a:bodyPr wrap="square">
+            <a:spAutoFit/>
+          </a:bodyPr>
+          <a:lstStyle/>
           <a:p>
             <a:pPr>
-              <a:spcBef>
-                <a:spcPts val="1400"/>
-              </a:spcBef>
-              <a:defRPr sz="2000" b="1">
+              <a:spcAft>
+                <a:spcPts val="1200"/>
+              </a:spcAft>
+              <a:defRPr sz="1800" b="1">
                 <a:solidFill>
                   <a:srgbClr val="00DFD8"/>
                 </a:solidFill>
@@ -4476,7 +6893,7 @@
               </a:defRPr>
             </a:pPr>
             <a:r>
-              <a:t>Continuous Speech Recognition</a:t>
+              <a:t>Speech Recognition</a:t>
             </a:r>
           </a:p>
           <a:p>
@@ -4484,7 +6901,7 @@
               <a:spcBef>
                 <a:spcPts val="400"/>
               </a:spcBef>
-              <a:defRPr sz="1500">
+              <a:defRPr sz="1350">
                 <a:solidFill>
                   <a:srgbClr val="FFFFFF"/>
                 </a:solidFill>
@@ -4495,12 +6912,123 @@
               <a:t>Integrated with the Web Speech API (webkitSpeechRecognition) configured for continuous listening and automatic restart, facilitating natural voice responses.</a:t>
             </a:r>
           </a:p>
+        </p:txBody>
+      </p:sp>
+      <p:sp>
+        <p:nvSpPr>
+          <p:cNvPr id="10" name="Rectangle 9"/>
+          <p:cNvSpPr/>
+          <p:nvPr/>
+        </p:nvSpPr>
+        <p:spPr>
+          <a:xfrm>
+            <a:off x="8119872" y="1645920"/>
+            <a:ext cx="3328416" cy="4389120"/>
+          </a:xfrm>
+          <a:prstGeom prst="rect">
+            <a:avLst/>
+          </a:prstGeom>
+          <a:solidFill>
+            <a:srgbClr val="161626"/>
+          </a:solidFill>
+          <a:ln w="12700">
+            <a:solidFill>
+              <a:srgbClr val="23233C"/>
+            </a:solidFill>
+          </a:ln>
+        </p:spPr>
+        <p:style>
+          <a:lnRef idx="1">
+            <a:schemeClr val="accent1"/>
+          </a:lnRef>
+          <a:fillRef idx="3">
+            <a:schemeClr val="accent1"/>
+          </a:fillRef>
+          <a:effectRef idx="2">
+            <a:schemeClr val="accent1"/>
+          </a:effectRef>
+          <a:fontRef idx="minor">
+            <a:schemeClr val="lt1"/>
+          </a:fontRef>
+        </p:style>
+        <p:txBody>
+          <a:bodyPr rtlCol="0" anchor="ctr"/>
+          <a:lstStyle/>
+          <a:p>
+            <a:pPr algn="ctr"/>
+          </a:p>
+        </p:txBody>
+      </p:sp>
+      <p:sp>
+        <p:nvSpPr>
+          <p:cNvPr id="11" name="Rectangle 10"/>
+          <p:cNvSpPr/>
+          <p:nvPr/>
+        </p:nvSpPr>
+        <p:spPr>
+          <a:xfrm>
+            <a:off x="8119872" y="1645920"/>
+            <a:ext cx="3328416" cy="50800"/>
+          </a:xfrm>
+          <a:prstGeom prst="rect">
+            <a:avLst/>
+          </a:prstGeom>
+          <a:solidFill>
+            <a:srgbClr val="00DFD8"/>
+          </a:solidFill>
+          <a:ln>
+            <a:noFill/>
+          </a:ln>
+        </p:spPr>
+        <p:style>
+          <a:lnRef idx="1">
+            <a:schemeClr val="accent1"/>
+          </a:lnRef>
+          <a:fillRef idx="3">
+            <a:schemeClr val="accent1"/>
+          </a:fillRef>
+          <a:effectRef idx="2">
+            <a:schemeClr val="accent1"/>
+          </a:effectRef>
+          <a:fontRef idx="minor">
+            <a:schemeClr val="lt1"/>
+          </a:fontRef>
+        </p:style>
+        <p:txBody>
+          <a:bodyPr rtlCol="0" anchor="ctr"/>
+          <a:lstStyle/>
+          <a:p>
+            <a:pPr algn="ctr"/>
+          </a:p>
+        </p:txBody>
+      </p:sp>
+      <p:sp>
+        <p:nvSpPr>
+          <p:cNvPr id="12" name="TextBox 11"/>
+          <p:cNvSpPr txBox="1"/>
+          <p:nvPr/>
+        </p:nvSpPr>
+        <p:spPr>
+          <a:xfrm>
+            <a:off x="8302752" y="1920240"/>
+            <a:ext cx="2962656" cy="3931920"/>
+          </a:xfrm>
+          <a:prstGeom prst="rect">
+            <a:avLst/>
+          </a:prstGeom>
+          <a:noFill/>
+        </p:spPr>
+        <p:txBody>
+          <a:bodyPr wrap="square">
+            <a:spAutoFit/>
+          </a:bodyPr>
+          <a:lstStyle/>
           <a:p>
             <a:pPr>
-              <a:spcBef>
-                <a:spcPts val="1400"/>
-              </a:spcBef>
-              <a:defRPr sz="2000" b="1">
+              <a:spcAft>
+                <a:spcPts val="1200"/>
+              </a:spcAft>
+              <a:defRPr sz="1800" b="1">
                 <a:solidFill>
                   <a:srgbClr val="00DFD8"/>
                 </a:solidFill>
@@ -4516,7 +7044,7 @@
               <a:spcBef>
                 <a:spcPts val="400"/>
               </a:spcBef>
-              <a:defRPr sz="1500">
+              <a:defRPr sz="1350">
                 <a:solidFill>
                   <a:srgbClr val="FFFFFF"/>
                 </a:solidFill>
@@ -4543,7 +7071,7 @@
     <p:bg>
       <p:bgPr>
         <a:solidFill>
-          <a:srgbClr val="0F0F1B"/>
+          <a:srgbClr val="0C0C14"/>
         </a:solidFill>
         <a:effectLst/>
       </p:bgPr>
@@ -4563,8 +7091,8 @@
         </p:nvSpPr>
         <p:spPr>
           <a:xfrm>
-            <a:off x="731520" y="457200"/>
-            <a:ext cx="10698480" cy="914400"/>
+            <a:off x="731520" y="365760"/>
+            <a:ext cx="10698480" cy="731520"/>
           </a:xfrm>
           <a:prstGeom prst="rect">
             <a:avLst/>
@@ -4578,7 +7106,7 @@
           <a:lstStyle/>
           <a:p>
             <a:pPr>
-              <a:defRPr sz="3600" b="1">
+              <a:defRPr sz="3200" b="1">
                 <a:solidFill>
                   <a:srgbClr val="00DFD8"/>
                 </a:solidFill>
@@ -4593,14 +7121,145 @@
       </p:sp>
       <p:sp>
         <p:nvSpPr>
-          <p:cNvPr id="3" name="TextBox 2"/>
+          <p:cNvPr id="3" name="Rectangle 2"/>
+          <p:cNvSpPr/>
+          <p:nvPr/>
+        </p:nvSpPr>
+        <p:spPr>
+          <a:xfrm>
+            <a:off x="731520" y="1097280"/>
+            <a:ext cx="10728655" cy="19050"/>
+          </a:xfrm>
+          <a:prstGeom prst="rect">
+            <a:avLst/>
+          </a:prstGeom>
+          <a:solidFill>
+            <a:srgbClr val="23233C"/>
+          </a:solidFill>
+          <a:ln>
+            <a:noFill/>
+          </a:ln>
+        </p:spPr>
+        <p:style>
+          <a:lnRef idx="1">
+            <a:schemeClr val="accent1"/>
+          </a:lnRef>
+          <a:fillRef idx="3">
+            <a:schemeClr val="accent1"/>
+          </a:fillRef>
+          <a:effectRef idx="2">
+            <a:schemeClr val="accent1"/>
+          </a:effectRef>
+          <a:fontRef idx="minor">
+            <a:schemeClr val="lt1"/>
+          </a:fontRef>
+        </p:style>
+        <p:txBody>
+          <a:bodyPr rtlCol="0" anchor="ctr"/>
+          <a:lstStyle/>
+          <a:p>
+            <a:pPr algn="ctr"/>
+          </a:p>
+        </p:txBody>
+      </p:sp>
+      <p:sp>
+        <p:nvSpPr>
+          <p:cNvPr id="4" name="Rectangle 3"/>
+          <p:cNvSpPr/>
+          <p:nvPr/>
+        </p:nvSpPr>
+        <p:spPr>
+          <a:xfrm>
+            <a:off x="731520" y="1645920"/>
+            <a:ext cx="3328416" cy="4389120"/>
+          </a:xfrm>
+          <a:prstGeom prst="rect">
+            <a:avLst/>
+          </a:prstGeom>
+          <a:solidFill>
+            <a:srgbClr val="161626"/>
+          </a:solidFill>
+          <a:ln w="12700">
+            <a:solidFill>
+              <a:srgbClr val="23233C"/>
+            </a:solidFill>
+          </a:ln>
+        </p:spPr>
+        <p:style>
+          <a:lnRef idx="1">
+            <a:schemeClr val="accent1"/>
+          </a:lnRef>
+          <a:fillRef idx="3">
+            <a:schemeClr val="accent1"/>
+          </a:fillRef>
+          <a:effectRef idx="2">
+            <a:schemeClr val="accent1"/>
+          </a:effectRef>
+          <a:fontRef idx="minor">
+            <a:schemeClr val="lt1"/>
+          </a:fontRef>
+        </p:style>
+        <p:txBody>
+          <a:bodyPr rtlCol="0" anchor="ctr"/>
+          <a:lstStyle/>
+          <a:p>
+            <a:pPr algn="ctr"/>
+          </a:p>
+        </p:txBody>
+      </p:sp>
+      <p:sp>
+        <p:nvSpPr>
+          <p:cNvPr id="5" name="Rectangle 4"/>
+          <p:cNvSpPr/>
+          <p:nvPr/>
+        </p:nvSpPr>
+        <p:spPr>
+          <a:xfrm>
+            <a:off x="731520" y="1645920"/>
+            <a:ext cx="3328416" cy="50800"/>
+          </a:xfrm>
+          <a:prstGeom prst="rect">
+            <a:avLst/>
+          </a:prstGeom>
+          <a:solidFill>
+            <a:srgbClr val="00DFD8"/>
+          </a:solidFill>
+          <a:ln>
+            <a:noFill/>
+          </a:ln>
+        </p:spPr>
+        <p:style>
+          <a:lnRef idx="1">
+            <a:schemeClr val="accent1"/>
+          </a:lnRef>
+          <a:fillRef idx="3">
+            <a:schemeClr val="accent1"/>
+          </a:fillRef>
+          <a:effectRef idx="2">
+            <a:schemeClr val="accent1"/>
+          </a:effectRef>
+          <a:fontRef idx="minor">
+            <a:schemeClr val="lt1"/>
+          </a:fontRef>
+        </p:style>
+        <p:txBody>
+          <a:bodyPr rtlCol="0" anchor="ctr"/>
+          <a:lstStyle/>
+          <a:p>
+            <a:pPr algn="ctr"/>
+          </a:p>
+        </p:txBody>
+      </p:sp>
+      <p:sp>
+        <p:nvSpPr>
+          <p:cNvPr id="6" name="TextBox 5"/>
           <p:cNvSpPr txBox="1"/>
           <p:nvPr/>
         </p:nvSpPr>
         <p:spPr>
           <a:xfrm>
-            <a:off x="731520" y="1645920"/>
-            <a:ext cx="10698480" cy="4572000"/>
+            <a:off x="914400" y="1920240"/>
+            <a:ext cx="2962656" cy="3931920"/>
           </a:xfrm>
           <a:prstGeom prst="rect">
             <a:avLst/>
@@ -4614,10 +7273,10 @@
           <a:lstStyle/>
           <a:p>
             <a:pPr>
-              <a:spcBef>
-                <a:spcPts val="1400"/>
-              </a:spcBef>
-              <a:defRPr sz="2000" b="1">
+              <a:spcAft>
+                <a:spcPts val="1200"/>
+              </a:spcAft>
+              <a:defRPr sz="1800" b="1">
                 <a:solidFill>
                   <a:srgbClr val="00DFD8"/>
                 </a:solidFill>
@@ -4633,7 +7292,7 @@
               <a:spcBef>
                 <a:spcPts val="400"/>
               </a:spcBef>
-              <a:defRPr sz="1500">
+              <a:defRPr sz="1350">
                 <a:solidFill>
                   <a:srgbClr val="FFFFFF"/>
                 </a:solidFill>
@@ -4644,12 +7303,123 @@
               <a:t>Access is protected using JSON Web Tokens (JWT) encrypted with bcrypt hashing for secure session logins.</a:t>
             </a:r>
           </a:p>
+        </p:txBody>
+      </p:sp>
+      <p:sp>
+        <p:nvSpPr>
+          <p:cNvPr id="7" name="Rectangle 6"/>
+          <p:cNvSpPr/>
+          <p:nvPr/>
+        </p:nvSpPr>
+        <p:spPr>
+          <a:xfrm>
+            <a:off x="4425696" y="1645920"/>
+            <a:ext cx="3328416" cy="4389120"/>
+          </a:xfrm>
+          <a:prstGeom prst="rect">
+            <a:avLst/>
+          </a:prstGeom>
+          <a:solidFill>
+            <a:srgbClr val="161626"/>
+          </a:solidFill>
+          <a:ln w="12700">
+            <a:solidFill>
+              <a:srgbClr val="23233C"/>
+            </a:solidFill>
+          </a:ln>
+        </p:spPr>
+        <p:style>
+          <a:lnRef idx="1">
+            <a:schemeClr val="accent1"/>
+          </a:lnRef>
+          <a:fillRef idx="3">
+            <a:schemeClr val="accent1"/>
+          </a:fillRef>
+          <a:effectRef idx="2">
+            <a:schemeClr val="accent1"/>
+          </a:effectRef>
+          <a:fontRef idx="minor">
+            <a:schemeClr val="lt1"/>
+          </a:fontRef>
+        </p:style>
+        <p:txBody>
+          <a:bodyPr rtlCol="0" anchor="ctr"/>
+          <a:lstStyle/>
+          <a:p>
+            <a:pPr algn="ctr"/>
+          </a:p>
+        </p:txBody>
+      </p:sp>
+      <p:sp>
+        <p:nvSpPr>
+          <p:cNvPr id="8" name="Rectangle 7"/>
+          <p:cNvSpPr/>
+          <p:nvPr/>
+        </p:nvSpPr>
+        <p:spPr>
+          <a:xfrm>
+            <a:off x="4425696" y="1645920"/>
+            <a:ext cx="3328416" cy="50800"/>
+          </a:xfrm>
+          <a:prstGeom prst="rect">
+            <a:avLst/>
+          </a:prstGeom>
+          <a:solidFill>
+            <a:srgbClr val="00DFD8"/>
+          </a:solidFill>
+          <a:ln>
+            <a:noFill/>
+          </a:ln>
+        </p:spPr>
+        <p:style>
+          <a:lnRef idx="1">
+            <a:schemeClr val="accent1"/>
+          </a:lnRef>
+          <a:fillRef idx="3">
+            <a:schemeClr val="accent1"/>
+          </a:fillRef>
+          <a:effectRef idx="2">
+            <a:schemeClr val="accent1"/>
+          </a:effectRef>
+          <a:fontRef idx="minor">
+            <a:schemeClr val="lt1"/>
+          </a:fontRef>
+        </p:style>
+        <p:txBody>
+          <a:bodyPr rtlCol="0" anchor="ctr"/>
+          <a:lstStyle/>
+          <a:p>
+            <a:pPr algn="ctr"/>
+          </a:p>
+        </p:txBody>
+      </p:sp>
+      <p:sp>
+        <p:nvSpPr>
+          <p:cNvPr id="9" name="TextBox 8"/>
+          <p:cNvSpPr txBox="1"/>
+          <p:nvPr/>
+        </p:nvSpPr>
+        <p:spPr>
+          <a:xfrm>
+            <a:off x="4608576" y="1920240"/>
+            <a:ext cx="2962656" cy="3931920"/>
+          </a:xfrm>
+          <a:prstGeom prst="rect">
+            <a:avLst/>
+          </a:prstGeom>
+          <a:noFill/>
+        </p:spPr>
+        <p:txBody>
+          <a:bodyPr wrap="square">
+            <a:spAutoFit/>
+          </a:bodyPr>
+          <a:lstStyle/>
           <a:p>
             <a:pPr>
-              <a:spcBef>
-                <a:spcPts val="1400"/>
-              </a:spcBef>
-              <a:defRPr sz="2000" b="1">
+              <a:spcAft>
+                <a:spcPts val="1200"/>
+              </a:spcAft>
+              <a:defRPr sz="1800" b="1">
                 <a:solidFill>
                   <a:srgbClr val="00DFD8"/>
                 </a:solidFill>
@@ -4665,7 +7435,7 @@
               <a:spcBef>
                 <a:spcPts val="400"/>
               </a:spcBef>
-              <a:defRPr sz="1500">
+              <a:defRPr sz="1350">
                 <a:solidFill>
                   <a:srgbClr val="FFFFFF"/>
                 </a:solidFill>
@@ -4676,12 +7446,123 @@
               <a:t>Multi-tenant workspace isolation ensures recruiters only see and manage their own jobs, candidate uploads, and logs.</a:t>
             </a:r>
           </a:p>
+        </p:txBody>
+      </p:sp>
+      <p:sp>
+        <p:nvSpPr>
+          <p:cNvPr id="10" name="Rectangle 9"/>
+          <p:cNvSpPr/>
+          <p:nvPr/>
+        </p:nvSpPr>
+        <p:spPr>
+          <a:xfrm>
+            <a:off x="8119872" y="1645920"/>
+            <a:ext cx="3328416" cy="4389120"/>
+          </a:xfrm>
+          <a:prstGeom prst="rect">
+            <a:avLst/>
+          </a:prstGeom>
+          <a:solidFill>
+            <a:srgbClr val="161626"/>
+          </a:solidFill>
+          <a:ln w="12700">
+            <a:solidFill>
+              <a:srgbClr val="23233C"/>
+            </a:solidFill>
+          </a:ln>
+        </p:spPr>
+        <p:style>
+          <a:lnRef idx="1">
+            <a:schemeClr val="accent1"/>
+          </a:lnRef>
+          <a:fillRef idx="3">
+            <a:schemeClr val="accent1"/>
+          </a:fillRef>
+          <a:effectRef idx="2">
+            <a:schemeClr val="accent1"/>
+          </a:effectRef>
+          <a:fontRef idx="minor">
+            <a:schemeClr val="lt1"/>
+          </a:fontRef>
+        </p:style>
+        <p:txBody>
+          <a:bodyPr rtlCol="0" anchor="ctr"/>
+          <a:lstStyle/>
+          <a:p>
+            <a:pPr algn="ctr"/>
+          </a:p>
+        </p:txBody>
+      </p:sp>
+      <p:sp>
+        <p:nvSpPr>
+          <p:cNvPr id="11" name="Rectangle 10"/>
+          <p:cNvSpPr/>
+          <p:nvPr/>
+        </p:nvSpPr>
+        <p:spPr>
+          <a:xfrm>
+            <a:off x="8119872" y="1645920"/>
+            <a:ext cx="3328416" cy="50800"/>
+          </a:xfrm>
+          <a:prstGeom prst="rect">
+            <a:avLst/>
+          </a:prstGeom>
+          <a:solidFill>
+            <a:srgbClr val="00DFD8"/>
+          </a:solidFill>
+          <a:ln>
+            <a:noFill/>
+          </a:ln>
+        </p:spPr>
+        <p:style>
+          <a:lnRef idx="1">
+            <a:schemeClr val="accent1"/>
+          </a:lnRef>
+          <a:fillRef idx="3">
+            <a:schemeClr val="accent1"/>
+          </a:fillRef>
+          <a:effectRef idx="2">
+            <a:schemeClr val="accent1"/>
+          </a:effectRef>
+          <a:fontRef idx="minor">
+            <a:schemeClr val="lt1"/>
+          </a:fontRef>
+        </p:style>
+        <p:txBody>
+          <a:bodyPr rtlCol="0" anchor="ctr"/>
+          <a:lstStyle/>
+          <a:p>
+            <a:pPr algn="ctr"/>
+          </a:p>
+        </p:txBody>
+      </p:sp>
+      <p:sp>
+        <p:nvSpPr>
+          <p:cNvPr id="12" name="TextBox 11"/>
+          <p:cNvSpPr txBox="1"/>
+          <p:nvPr/>
+        </p:nvSpPr>
+        <p:spPr>
+          <a:xfrm>
+            <a:off x="8302752" y="1920240"/>
+            <a:ext cx="2962656" cy="3931920"/>
+          </a:xfrm>
+          <a:prstGeom prst="rect">
+            <a:avLst/>
+          </a:prstGeom>
+          <a:noFill/>
+        </p:spPr>
+        <p:txBody>
+          <a:bodyPr wrap="square">
+            <a:spAutoFit/>
+          </a:bodyPr>
+          <a:lstStyle/>
           <a:p>
             <a:pPr>
-              <a:spcBef>
-                <a:spcPts val="1400"/>
-              </a:spcBef>
-              <a:defRPr sz="2000" b="1">
+              <a:spcAft>
+                <a:spcPts val="1200"/>
+              </a:spcAft>
+              <a:defRPr sz="1800" b="1">
                 <a:solidFill>
                   <a:srgbClr val="00DFD8"/>
                 </a:solidFill>
@@ -4697,7 +7578,7 @@
               <a:spcBef>
                 <a:spcPts val="400"/>
               </a:spcBef>
-              <a:defRPr sz="1500">
+              <a:defRPr sz="1350">
                 <a:solidFill>
                   <a:srgbClr val="FFFFFF"/>
                 </a:solidFill>
@@ -4724,7 +7605,7 @@
     <p:bg>
       <p:bgPr>
         <a:solidFill>
-          <a:srgbClr val="0F0F1B"/>
+          <a:srgbClr val="0C0C14"/>
         </a:solidFill>
         <a:effectLst/>
       </p:bgPr>
@@ -4744,8 +7625,8 @@
         </p:nvSpPr>
         <p:spPr>
           <a:xfrm>
-            <a:off x="731520" y="457200"/>
-            <a:ext cx="10698480" cy="914400"/>
+            <a:off x="731520" y="365760"/>
+            <a:ext cx="10698480" cy="731520"/>
           </a:xfrm>
           <a:prstGeom prst="rect">
             <a:avLst/>
@@ -4759,7 +7640,7 @@
           <a:lstStyle/>
           <a:p>
             <a:pPr>
-              <a:defRPr sz="3600" b="1">
+              <a:defRPr sz="3200" b="1">
                 <a:solidFill>
                   <a:srgbClr val="00DFD8"/>
                 </a:solidFill>
@@ -4774,14 +7655,145 @@
       </p:sp>
       <p:sp>
         <p:nvSpPr>
-          <p:cNvPr id="3" name="TextBox 2"/>
+          <p:cNvPr id="3" name="Rectangle 2"/>
+          <p:cNvSpPr/>
+          <p:nvPr/>
+        </p:nvSpPr>
+        <p:spPr>
+          <a:xfrm>
+            <a:off x="731520" y="1097280"/>
+            <a:ext cx="10728655" cy="19050"/>
+          </a:xfrm>
+          <a:prstGeom prst="rect">
+            <a:avLst/>
+          </a:prstGeom>
+          <a:solidFill>
+            <a:srgbClr val="23233C"/>
+          </a:solidFill>
+          <a:ln>
+            <a:noFill/>
+          </a:ln>
+        </p:spPr>
+        <p:style>
+          <a:lnRef idx="1">
+            <a:schemeClr val="accent1"/>
+          </a:lnRef>
+          <a:fillRef idx="3">
+            <a:schemeClr val="accent1"/>
+          </a:fillRef>
+          <a:effectRef idx="2">
+            <a:schemeClr val="accent1"/>
+          </a:effectRef>
+          <a:fontRef idx="minor">
+            <a:schemeClr val="lt1"/>
+          </a:fontRef>
+        </p:style>
+        <p:txBody>
+          <a:bodyPr rtlCol="0" anchor="ctr"/>
+          <a:lstStyle/>
+          <a:p>
+            <a:pPr algn="ctr"/>
+          </a:p>
+        </p:txBody>
+      </p:sp>
+      <p:sp>
+        <p:nvSpPr>
+          <p:cNvPr id="4" name="Rectangle 3"/>
+          <p:cNvSpPr/>
+          <p:nvPr/>
+        </p:nvSpPr>
+        <p:spPr>
+          <a:xfrm>
+            <a:off x="731520" y="1645920"/>
+            <a:ext cx="3328416" cy="4389120"/>
+          </a:xfrm>
+          <a:prstGeom prst="rect">
+            <a:avLst/>
+          </a:prstGeom>
+          <a:solidFill>
+            <a:srgbClr val="161626"/>
+          </a:solidFill>
+          <a:ln w="12700">
+            <a:solidFill>
+              <a:srgbClr val="23233C"/>
+            </a:solidFill>
+          </a:ln>
+        </p:spPr>
+        <p:style>
+          <a:lnRef idx="1">
+            <a:schemeClr val="accent1"/>
+          </a:lnRef>
+          <a:fillRef idx="3">
+            <a:schemeClr val="accent1"/>
+          </a:fillRef>
+          <a:effectRef idx="2">
+            <a:schemeClr val="accent1"/>
+          </a:effectRef>
+          <a:fontRef idx="minor">
+            <a:schemeClr val="lt1"/>
+          </a:fontRef>
+        </p:style>
+        <p:txBody>
+          <a:bodyPr rtlCol="0" anchor="ctr"/>
+          <a:lstStyle/>
+          <a:p>
+            <a:pPr algn="ctr"/>
+          </a:p>
+        </p:txBody>
+      </p:sp>
+      <p:sp>
+        <p:nvSpPr>
+          <p:cNvPr id="5" name="Rectangle 4"/>
+          <p:cNvSpPr/>
+          <p:nvPr/>
+        </p:nvSpPr>
+        <p:spPr>
+          <a:xfrm>
+            <a:off x="731520" y="1645920"/>
+            <a:ext cx="3328416" cy="50800"/>
+          </a:xfrm>
+          <a:prstGeom prst="rect">
+            <a:avLst/>
+          </a:prstGeom>
+          <a:solidFill>
+            <a:srgbClr val="00DFD8"/>
+          </a:solidFill>
+          <a:ln>
+            <a:noFill/>
+          </a:ln>
+        </p:spPr>
+        <p:style>
+          <a:lnRef idx="1">
+            <a:schemeClr val="accent1"/>
+          </a:lnRef>
+          <a:fillRef idx="3">
+            <a:schemeClr val="accent1"/>
+          </a:fillRef>
+          <a:effectRef idx="2">
+            <a:schemeClr val="accent1"/>
+          </a:effectRef>
+          <a:fontRef idx="minor">
+            <a:schemeClr val="lt1"/>
+          </a:fontRef>
+        </p:style>
+        <p:txBody>
+          <a:bodyPr rtlCol="0" anchor="ctr"/>
+          <a:lstStyle/>
+          <a:p>
+            <a:pPr algn="ctr"/>
+          </a:p>
+        </p:txBody>
+      </p:sp>
+      <p:sp>
+        <p:nvSpPr>
+          <p:cNvPr id="6" name="TextBox 5"/>
           <p:cNvSpPr txBox="1"/>
           <p:nvPr/>
         </p:nvSpPr>
         <p:spPr>
           <a:xfrm>
-            <a:off x="731520" y="1645920"/>
-            <a:ext cx="10698480" cy="4572000"/>
+            <a:off x="914400" y="1920240"/>
+            <a:ext cx="2962656" cy="3931920"/>
           </a:xfrm>
           <a:prstGeom prst="rect">
             <a:avLst/>
@@ -4795,10 +7807,10 @@
           <a:lstStyle/>
           <a:p>
             <a:pPr>
-              <a:spcBef>
-                <a:spcPts val="1400"/>
-              </a:spcBef>
-              <a:defRPr sz="2000" b="1">
+              <a:spcAft>
+                <a:spcPts val="1200"/>
+              </a:spcAft>
+              <a:defRPr sz="1800" b="1">
                 <a:solidFill>
                   <a:srgbClr val="00DFD8"/>
                 </a:solidFill>
@@ -4814,7 +7826,7 @@
               <a:spcBef>
                 <a:spcPts val="400"/>
               </a:spcBef>
-              <a:defRPr sz="1500">
+              <a:defRPr sz="1350">
                 <a:solidFill>
                   <a:srgbClr val="FFFFFF"/>
                 </a:solidFill>
@@ -4825,12 +7837,123 @@
               <a:t>All backend diagnostic suites passed: JWT security cryptography, CSV profile ingestion, regex extractors, and workspace isolation.</a:t>
             </a:r>
           </a:p>
+        </p:txBody>
+      </p:sp>
+      <p:sp>
+        <p:nvSpPr>
+          <p:cNvPr id="7" name="Rectangle 6"/>
+          <p:cNvSpPr/>
+          <p:nvPr/>
+        </p:nvSpPr>
+        <p:spPr>
+          <a:xfrm>
+            <a:off x="4425696" y="1645920"/>
+            <a:ext cx="3328416" cy="4389120"/>
+          </a:xfrm>
+          <a:prstGeom prst="rect">
+            <a:avLst/>
+          </a:prstGeom>
+          <a:solidFill>
+            <a:srgbClr val="161626"/>
+          </a:solidFill>
+          <a:ln w="12700">
+            <a:solidFill>
+              <a:srgbClr val="23233C"/>
+            </a:solidFill>
+          </a:ln>
+        </p:spPr>
+        <p:style>
+          <a:lnRef idx="1">
+            <a:schemeClr val="accent1"/>
+          </a:lnRef>
+          <a:fillRef idx="3">
+            <a:schemeClr val="accent1"/>
+          </a:fillRef>
+          <a:effectRef idx="2">
+            <a:schemeClr val="accent1"/>
+          </a:effectRef>
+          <a:fontRef idx="minor">
+            <a:schemeClr val="lt1"/>
+          </a:fontRef>
+        </p:style>
+        <p:txBody>
+          <a:bodyPr rtlCol="0" anchor="ctr"/>
+          <a:lstStyle/>
+          <a:p>
+            <a:pPr algn="ctr"/>
+          </a:p>
+        </p:txBody>
+      </p:sp>
+      <p:sp>
+        <p:nvSpPr>
+          <p:cNvPr id="8" name="Rectangle 7"/>
+          <p:cNvSpPr/>
+          <p:nvPr/>
+        </p:nvSpPr>
+        <p:spPr>
+          <a:xfrm>
+            <a:off x="4425696" y="1645920"/>
+            <a:ext cx="3328416" cy="50800"/>
+          </a:xfrm>
+          <a:prstGeom prst="rect">
+            <a:avLst/>
+          </a:prstGeom>
+          <a:solidFill>
+            <a:srgbClr val="00DFD8"/>
+          </a:solidFill>
+          <a:ln>
+            <a:noFill/>
+          </a:ln>
+        </p:spPr>
+        <p:style>
+          <a:lnRef idx="1">
+            <a:schemeClr val="accent1"/>
+          </a:lnRef>
+          <a:fillRef idx="3">
+            <a:schemeClr val="accent1"/>
+          </a:fillRef>
+          <a:effectRef idx="2">
+            <a:schemeClr val="accent1"/>
+          </a:effectRef>
+          <a:fontRef idx="minor">
+            <a:schemeClr val="lt1"/>
+          </a:fontRef>
+        </p:style>
+        <p:txBody>
+          <a:bodyPr rtlCol="0" anchor="ctr"/>
+          <a:lstStyle/>
+          <a:p>
+            <a:pPr algn="ctr"/>
+          </a:p>
+        </p:txBody>
+      </p:sp>
+      <p:sp>
+        <p:nvSpPr>
+          <p:cNvPr id="9" name="TextBox 8"/>
+          <p:cNvSpPr txBox="1"/>
+          <p:nvPr/>
+        </p:nvSpPr>
+        <p:spPr>
+          <a:xfrm>
+            <a:off x="4608576" y="1920240"/>
+            <a:ext cx="2962656" cy="3931920"/>
+          </a:xfrm>
+          <a:prstGeom prst="rect">
+            <a:avLst/>
+          </a:prstGeom>
+          <a:noFill/>
+        </p:spPr>
+        <p:txBody>
+          <a:bodyPr wrap="square">
+            <a:spAutoFit/>
+          </a:bodyPr>
+          <a:lstStyle/>
           <a:p>
             <a:pPr>
-              <a:spcBef>
-                <a:spcPts val="1400"/>
-              </a:spcBef>
-              <a:defRPr sz="2000" b="1">
+              <a:spcAft>
+                <a:spcPts val="1200"/>
+              </a:spcAft>
+              <a:defRPr sz="1800" b="1">
                 <a:solidFill>
                   <a:srgbClr val="00DFD8"/>
                 </a:solidFill>
@@ -4846,7 +7969,7 @@
               <a:spcBef>
                 <a:spcPts val="400"/>
               </a:spcBef>
-              <a:defRPr sz="1500">
+              <a:defRPr sz="1350">
                 <a:solidFill>
                   <a:srgbClr val="FFFFFF"/>
                 </a:solidFill>
@@ -4857,12 +7980,123 @@
               <a:t>Local embedding generation avoids high external API invocation costs, making the platform highly scalable.</a:t>
             </a:r>
           </a:p>
+        </p:txBody>
+      </p:sp>
+      <p:sp>
+        <p:nvSpPr>
+          <p:cNvPr id="10" name="Rectangle 9"/>
+          <p:cNvSpPr/>
+          <p:nvPr/>
+        </p:nvSpPr>
+        <p:spPr>
+          <a:xfrm>
+            <a:off x="8119872" y="1645920"/>
+            <a:ext cx="3328416" cy="4389120"/>
+          </a:xfrm>
+          <a:prstGeom prst="rect">
+            <a:avLst/>
+          </a:prstGeom>
+          <a:solidFill>
+            <a:srgbClr val="161626"/>
+          </a:solidFill>
+          <a:ln w="12700">
+            <a:solidFill>
+              <a:srgbClr val="23233C"/>
+            </a:solidFill>
+          </a:ln>
+        </p:spPr>
+        <p:style>
+          <a:lnRef idx="1">
+            <a:schemeClr val="accent1"/>
+          </a:lnRef>
+          <a:fillRef idx="3">
+            <a:schemeClr val="accent1"/>
+          </a:fillRef>
+          <a:effectRef idx="2">
+            <a:schemeClr val="accent1"/>
+          </a:effectRef>
+          <a:fontRef idx="minor">
+            <a:schemeClr val="lt1"/>
+          </a:fontRef>
+        </p:style>
+        <p:txBody>
+          <a:bodyPr rtlCol="0" anchor="ctr"/>
+          <a:lstStyle/>
+          <a:p>
+            <a:pPr algn="ctr"/>
+          </a:p>
+        </p:txBody>
+      </p:sp>
+      <p:sp>
+        <p:nvSpPr>
+          <p:cNvPr id="11" name="Rectangle 10"/>
+          <p:cNvSpPr/>
+          <p:nvPr/>
+        </p:nvSpPr>
+        <p:spPr>
+          <a:xfrm>
+            <a:off x="8119872" y="1645920"/>
+            <a:ext cx="3328416" cy="50800"/>
+          </a:xfrm>
+          <a:prstGeom prst="rect">
+            <a:avLst/>
+          </a:prstGeom>
+          <a:solidFill>
+            <a:srgbClr val="00DFD8"/>
+          </a:solidFill>
+          <a:ln>
+            <a:noFill/>
+          </a:ln>
+        </p:spPr>
+        <p:style>
+          <a:lnRef idx="1">
+            <a:schemeClr val="accent1"/>
+          </a:lnRef>
+          <a:fillRef idx="3">
+            <a:schemeClr val="accent1"/>
+          </a:fillRef>
+          <a:effectRef idx="2">
+            <a:schemeClr val="accent1"/>
+          </a:effectRef>
+          <a:fontRef idx="minor">
+            <a:schemeClr val="lt1"/>
+          </a:fontRef>
+        </p:style>
+        <p:txBody>
+          <a:bodyPr rtlCol="0" anchor="ctr"/>
+          <a:lstStyle/>
+          <a:p>
+            <a:pPr algn="ctr"/>
+          </a:p>
+        </p:txBody>
+      </p:sp>
+      <p:sp>
+        <p:nvSpPr>
+          <p:cNvPr id="12" name="TextBox 11"/>
+          <p:cNvSpPr txBox="1"/>
+          <p:nvPr/>
+        </p:nvSpPr>
+        <p:spPr>
+          <a:xfrm>
+            <a:off x="8302752" y="1920240"/>
+            <a:ext cx="2962656" cy="3931920"/>
+          </a:xfrm>
+          <a:prstGeom prst="rect">
+            <a:avLst/>
+          </a:prstGeom>
+          <a:noFill/>
+        </p:spPr>
+        <p:txBody>
+          <a:bodyPr wrap="square">
+            <a:spAutoFit/>
+          </a:bodyPr>
+          <a:lstStyle/>
           <a:p>
             <a:pPr>
-              <a:spcBef>
-                <a:spcPts val="1400"/>
-              </a:spcBef>
-              <a:defRPr sz="2000" b="1">
+              <a:spcAft>
+                <a:spcPts val="1200"/>
+              </a:spcAft>
+              <a:defRPr sz="1800" b="1">
                 <a:solidFill>
                   <a:srgbClr val="00DFD8"/>
                 </a:solidFill>
@@ -4878,7 +8112,7 @@
               <a:spcBef>
                 <a:spcPts val="400"/>
               </a:spcBef>
-              <a:defRPr sz="1500">
+              <a:defRPr sz="1350">
                 <a:solidFill>
                   <a:srgbClr val="FFFFFF"/>
                 </a:solidFill>

</xml_diff>